<commit_message>
Deploy interactive prototype to GitHub Pages and add live link + QR code to Slide 6
</commit_message>
<xml_diff>
--- a/docs/SIH26053_TeraPulse_Official_Presentation.pptx
+++ b/docs/SIH26053_TeraPulse_Official_Presentation.pptx
@@ -8829,15 +8829,14 @@
           <a:lstStyle/>
           <a:p>
             <a:pPr>
-              <a:defRPr sz="1900" b="1" u="sng">
-                <a:solidFill>
-                  <a:srgbClr val="1F487C"/>
-                </a:solidFill>
-                <a:latin typeface="Arial"/>
+              <a:defRPr sz="1300" b="1">
+                <a:solidFill>
+                  <a:srgbClr val="1034A6"/>
+                </a:solidFill>
               </a:defRPr>
             </a:pPr>
             <a:r>
-              <a:t>Project Deliverables &amp; Repository</a:t>
+              <a:t>Project Deliverables &amp; Live Interactive Prototype</a:t>
             </a:r>
           </a:p>
         </p:txBody>
@@ -8851,7 +8850,7 @@
         <p:spPr>
           <a:xfrm>
             <a:off x="5212080" y="5166360"/>
-            <a:ext cx="6309360" cy="1280160"/>
+            <a:ext cx="4572000" cy="1280160"/>
           </a:xfrm>
           <a:prstGeom prst="rect">
             <a:avLst/>
@@ -8866,101 +8865,186 @@
           <a:p>
             <a:pPr>
               <a:spcAft>
-                <a:spcPts val="200"/>
+                <a:spcPts val="400"/>
               </a:spcAft>
             </a:pPr>
             <a:r>
-              <a:rPr sz="1050" b="1">
-                <a:solidFill>
-                  <a:srgbClr val="000000"/>
-                </a:solidFill>
-                <a:latin typeface="Arial"/>
-              </a:rPr>
-              <a:t>• Interactive Web Simulator: </a:t>
-            </a:r>
-            <a:r>
-              <a:rPr sz="1050" b="0">
-                <a:solidFill>
-                  <a:srgbClr val="232323"/>
-                </a:solidFill>
-                <a:latin typeface="Arial"/>
-              </a:rPr>
-              <a:t>Flask REST API + 60 FPS HTML5 Canvas with live vehicle foveation.</a:t>
+              <a:rPr sz="1000" b="1">
+                <a:solidFill>
+                  <a:srgbClr val="1034A6"/>
+                </a:solidFill>
+              </a:rPr>
+              <a:t>• </a:t>
+            </a:r>
+            <a:r>
+              <a:rPr sz="950" b="1">
+                <a:solidFill>
+                  <a:srgbClr val="1E293B"/>
+                </a:solidFill>
+              </a:rPr>
+              <a:t>🌐 Live Working Prototype: </a:t>
+            </a:r>
+            <a:r>
+              <a:rPr sz="950" b="1" u="sng">
+                <a:solidFill>
+                  <a:srgbClr val="0284C7"/>
+                </a:solidFill>
+                <a:hlinkClick r:id="rId4"/>
+              </a:rPr>
+              <a:t>https://abhayverma628.github.io/SIH26053_Lidar/</a:t>
             </a:r>
           </a:p>
           <a:p>
             <a:pPr>
               <a:spcAft>
-                <a:spcPts val="200"/>
+                <a:spcPts val="400"/>
               </a:spcAft>
             </a:pPr>
             <a:r>
-              <a:rPr sz="1050" b="1">
-                <a:solidFill>
-                  <a:srgbClr val="000000"/>
-                </a:solidFill>
-                <a:latin typeface="Arial"/>
-              </a:rPr>
-              <a:t>• Automated Test Suite: </a:t>
-            </a:r>
-            <a:r>
-              <a:rPr sz="1050" b="0">
-                <a:solidFill>
-                  <a:srgbClr val="232323"/>
-                </a:solidFill>
-                <a:latin typeface="Arial"/>
-              </a:rPr>
-              <a:t>5/5 unit tests (tests/test_pipeline.py) passing in 4.0s.</a:t>
+              <a:rPr sz="1000" b="1">
+                <a:solidFill>
+                  <a:srgbClr val="1034A6"/>
+                </a:solidFill>
+              </a:rPr>
+              <a:t>• </a:t>
+            </a:r>
+            <a:r>
+              <a:rPr sz="950" b="1">
+                <a:solidFill>
+                  <a:srgbClr val="1E293B"/>
+                </a:solidFill>
+              </a:rPr>
+              <a:t>💻 GitHub Repository: </a:t>
+            </a:r>
+            <a:r>
+              <a:rPr sz="950" b="1" u="sng">
+                <a:solidFill>
+                  <a:srgbClr val="0284C7"/>
+                </a:solidFill>
+                <a:hlinkClick r:id="rId5"/>
+              </a:rPr>
+              <a:t>https://github.com/AbhayVerma628/SIH26053_Lidar</a:t>
             </a:r>
           </a:p>
           <a:p>
             <a:pPr>
               <a:spcAft>
-                <a:spcPts val="200"/>
+                <a:spcPts val="400"/>
               </a:spcAft>
             </a:pPr>
             <a:r>
-              <a:rPr sz="1050" b="1">
-                <a:solidFill>
-                  <a:srgbClr val="000000"/>
-                </a:solidFill>
-                <a:latin typeface="Arial"/>
-              </a:rPr>
-              <a:t>• GitHub Repository: </a:t>
-            </a:r>
-            <a:r>
-              <a:rPr sz="1050" b="0">
-                <a:solidFill>
-                  <a:srgbClr val="232323"/>
-                </a:solidFill>
-                <a:latin typeface="Arial"/>
-              </a:rPr>
-              <a:t>github.com/AbhayVerma628/SIH26053_Lidar (Open Source MIT License).</a:t>
+              <a:rPr sz="1000" b="1">
+                <a:solidFill>
+                  <a:srgbClr val="1034A6"/>
+                </a:solidFill>
+              </a:rPr>
+              <a:t>• </a:t>
+            </a:r>
+            <a:r>
+              <a:rPr sz="950" b="1">
+                <a:solidFill>
+                  <a:srgbClr val="1E293B"/>
+                </a:solidFill>
+              </a:rPr>
+              <a:t>🚀 Interactive Web Simulator: </a:t>
+            </a:r>
+            <a:r>
+              <a:rPr sz="950">
+                <a:solidFill>
+                  <a:srgbClr val="475569"/>
+                </a:solidFill>
+              </a:rPr>
+              <a:t>60 FPS HTML5 Canvas with dynamic foveation &amp; A* trajectory</a:t>
             </a:r>
           </a:p>
           <a:p>
             <a:pPr>
               <a:spcAft>
-                <a:spcPts val="200"/>
+                <a:spcPts val="400"/>
               </a:spcAft>
             </a:pPr>
             <a:r>
-              <a:rPr sz="1050" b="1">
-                <a:solidFill>
-                  <a:srgbClr val="000000"/>
-                </a:solidFill>
-                <a:latin typeface="Arial"/>
-              </a:rPr>
-              <a:t>• Telemetry &amp; Artifacts: </a:t>
-            </a:r>
-            <a:r>
-              <a:rPr sz="1050" b="0">
-                <a:solidFill>
-                  <a:srgbClr val="232323"/>
-                </a:solidFill>
-                <a:latin typeface="Arial"/>
-              </a:rPr>
-              <a:t>5-panel dashboard, 10 Hz vehicle telemetry CSV &amp; planned A* waypoints.</a:t>
+              <a:rPr sz="1000" b="1">
+                <a:solidFill>
+                  <a:srgbClr val="1034A6"/>
+                </a:solidFill>
+              </a:rPr>
+              <a:t>• </a:t>
+            </a:r>
+            <a:r>
+              <a:rPr sz="950" b="1">
+                <a:solidFill>
+                  <a:srgbClr val="1E293B"/>
+                </a:solidFill>
+              </a:rPr>
+              <a:t>📊 Telemetry &amp; Verification: </a:t>
+            </a:r>
+            <a:r>
+              <a:rPr sz="950">
+                <a:solidFill>
+                  <a:srgbClr val="475569"/>
+                </a:solidFill>
+              </a:rPr>
+              <a:t>5/5 unit tests passed, 10 Hz vehicle kinematics telemetry</a:t>
+            </a:r>
+          </a:p>
+        </p:txBody>
+      </p:sp>
+      <p:pic>
+        <p:nvPicPr>
+          <p:cNvPr id="14" name="Picture 13" descr="prototype_qr.png"/>
+          <p:cNvPicPr>
+            <a:picLocks noChangeAspect="1"/>
+          </p:cNvPicPr>
+          <p:nvPr/>
+        </p:nvPicPr>
+        <p:blipFill>
+          <a:blip r:embed="rId6"/>
+          <a:stretch>
+            <a:fillRect/>
+          </a:stretch>
+        </p:blipFill>
+        <p:spPr>
+          <a:xfrm>
+            <a:off x="9555480" y="4480560"/>
+            <a:ext cx="1234440" cy="1234440"/>
+          </a:xfrm>
+          <a:prstGeom prst="rect">
+            <a:avLst/>
+          </a:prstGeom>
+        </p:spPr>
+      </p:pic>
+      <p:sp>
+        <p:nvSpPr>
+          <p:cNvPr id="15" name="TextBox 14"/>
+          <p:cNvSpPr txBox="1"/>
+          <p:nvPr/>
+        </p:nvSpPr>
+        <p:spPr>
+          <a:xfrm>
+            <a:off x="9464040" y="5715000"/>
+            <a:ext cx="1417320" cy="320040"/>
+          </a:xfrm>
+          <a:prstGeom prst="rect">
+            <a:avLst/>
+          </a:prstGeom>
+          <a:noFill/>
+        </p:spPr>
+        <p:txBody>
+          <a:bodyPr wrap="none">
+            <a:spAutoFit/>
+          </a:bodyPr>
+          <a:lstStyle/>
+          <a:p>
+            <a:pPr algn="ctr">
+              <a:defRPr sz="850" b="1">
+                <a:solidFill>
+                  <a:srgbClr val="0284C7"/>
+                </a:solidFill>
+              </a:defRPr>
+            </a:pPr>
+            <a:r>
+              <a:t>Scan for Live Demo</a:t>
             </a:r>
           </a:p>
         </p:txBody>

</xml_diff>

<commit_message>
Restore official SIH template assets, remove top gray banners, and restore slide 6 images
</commit_message>
<xml_diff>
--- a/docs/SIH26053_TeraPulse_Official_Presentation.pptx
+++ b/docs/SIH26053_TeraPulse_Official_Presentation.pptx
@@ -3165,9 +3165,33 @@
           </a:p>
         </p:txBody>
       </p:sp>
-      <p:sp>
-        <p:nvSpPr>
-          <p:cNvPr id="4" name="TextBox 3"/>
+      <p:pic>
+        <p:nvPicPr>
+          <p:cNvPr id="4" name="Picture 3" descr="sih_logo.png"/>
+          <p:cNvPicPr>
+            <a:picLocks noChangeAspect="1"/>
+          </p:cNvPicPr>
+          <p:nvPr/>
+        </p:nvPicPr>
+        <p:blipFill>
+          <a:blip r:embed="rId2"/>
+          <a:stretch>
+            <a:fillRect/>
+          </a:stretch>
+        </p:blipFill>
+        <p:spPr>
+          <a:xfrm>
+            <a:off x="10241280" y="164592"/>
+            <a:ext cx="1508760" cy="712897"/>
+          </a:xfrm>
+          <a:prstGeom prst="rect">
+            <a:avLst/>
+          </a:prstGeom>
+        </p:spPr>
+      </p:pic>
+      <p:sp>
+        <p:nvSpPr>
+          <p:cNvPr id="5" name="TextBox 4"/>
           <p:cNvSpPr txBox="1"/>
           <p:nvPr/>
         </p:nvSpPr>
@@ -3389,6 +3413,30 @@
           </a:p>
         </p:txBody>
       </p:sp>
+      <p:pic>
+        <p:nvPicPr>
+          <p:cNvPr id="6" name="Picture 5" descr="sih_brain.png"/>
+          <p:cNvPicPr>
+            <a:picLocks noChangeAspect="1"/>
+          </p:cNvPicPr>
+          <p:nvPr/>
+        </p:nvPicPr>
+        <p:blipFill>
+          <a:blip r:embed="rId3"/>
+          <a:stretch>
+            <a:fillRect/>
+          </a:stretch>
+        </p:blipFill>
+        <p:spPr>
+          <a:xfrm>
+            <a:off x="7132320" y="2011680"/>
+            <a:ext cx="4754880" cy="5085000"/>
+          </a:xfrm>
+          <a:prstGeom prst="rect">
+            <a:avLst/>
+          </a:prstGeom>
+        </p:spPr>
+      </p:pic>
     </p:spTree>
   </p:cSld>
   <p:clrMapOvr>
@@ -3468,8 +3516,8 @@
       </p:sp>
       <p:sp>
         <p:nvSpPr>
-          <p:cNvPr id="3" name="Rectangle 2"/>
-          <p:cNvSpPr/>
+          <p:cNvPr id="3" name="TextBox 2"/>
+          <p:cNvSpPr txBox="1"/>
           <p:nvPr/>
         </p:nvSpPr>
         <p:spPr>
@@ -3480,29 +3528,15 @@
           <a:prstGeom prst="rect">
             <a:avLst/>
           </a:prstGeom>
-          <a:solidFill>
-            <a:srgbClr val="BFC0BF"/>
-          </a:solidFill>
+          <a:noFill/>
           <a:ln>
             <a:noFill/>
           </a:ln>
         </p:spPr>
-        <p:style>
-          <a:lnRef idx="1">
-            <a:schemeClr val="accent1"/>
-          </a:lnRef>
-          <a:fillRef idx="3">
-            <a:schemeClr val="accent1"/>
-          </a:fillRef>
-          <a:effectRef idx="2">
-            <a:schemeClr val="accent1"/>
-          </a:effectRef>
-          <a:fontRef idx="minor">
-            <a:schemeClr val="lt1"/>
-          </a:fontRef>
-        </p:style>
-        <p:txBody>
-          <a:bodyPr rtlCol="0" anchor="ctr" wrap="square" lIns="0" rIns="0" tIns="0" bIns="0"/>
+        <p:txBody>
+          <a:bodyPr wrap="square" anchor="ctr" lIns="0" rIns="0" tIns="0" bIns="0">
+            <a:spAutoFit/>
+          </a:bodyPr>
           <a:lstStyle/>
           <a:p>
             <a:pPr algn="ctr">
@@ -3519,9 +3553,33 @@
           </a:p>
         </p:txBody>
       </p:sp>
-      <p:sp>
-        <p:nvSpPr>
-          <p:cNvPr id="4" name="Rectangle 3"/>
+      <p:pic>
+        <p:nvPicPr>
+          <p:cNvPr id="4" name="Picture 3" descr="sih_logo.png"/>
+          <p:cNvPicPr>
+            <a:picLocks noChangeAspect="1"/>
+          </p:cNvPicPr>
+          <p:nvPr/>
+        </p:nvPicPr>
+        <p:blipFill>
+          <a:blip r:embed="rId2"/>
+          <a:stretch>
+            <a:fillRect/>
+          </a:stretch>
+        </p:blipFill>
+        <p:spPr>
+          <a:xfrm>
+            <a:off x="10241280" y="164592"/>
+            <a:ext cx="1508760" cy="712897"/>
+          </a:xfrm>
+          <a:prstGeom prst="rect">
+            <a:avLst/>
+          </a:prstGeom>
+        </p:spPr>
+      </p:pic>
+      <p:sp>
+        <p:nvSpPr>
+          <p:cNvPr id="5" name="Rectangle 4"/>
           <p:cNvSpPr/>
           <p:nvPr/>
         </p:nvSpPr>
@@ -3574,7 +3632,7 @@
       </p:sp>
       <p:sp>
         <p:nvSpPr>
-          <p:cNvPr id="5" name="TextBox 4"/>
+          <p:cNvPr id="6" name="TextBox 5"/>
           <p:cNvSpPr txBox="1"/>
           <p:nvPr/>
         </p:nvSpPr>
@@ -3610,7 +3668,7 @@
       </p:sp>
       <p:sp>
         <p:nvSpPr>
-          <p:cNvPr id="6" name="TextBox 5"/>
+          <p:cNvPr id="7" name="TextBox 6"/>
           <p:cNvSpPr txBox="1"/>
           <p:nvPr/>
         </p:nvSpPr>
@@ -3646,7 +3704,7 @@
       </p:sp>
       <p:sp>
         <p:nvSpPr>
-          <p:cNvPr id="7" name="TextBox 6"/>
+          <p:cNvPr id="8" name="TextBox 7"/>
           <p:cNvSpPr txBox="1"/>
           <p:nvPr/>
         </p:nvSpPr>
@@ -3819,7 +3877,7 @@
       </p:sp>
       <p:sp>
         <p:nvSpPr>
-          <p:cNvPr id="8" name="TextBox 7"/>
+          <p:cNvPr id="9" name="TextBox 8"/>
           <p:cNvSpPr txBox="1"/>
           <p:nvPr/>
         </p:nvSpPr>
@@ -3855,7 +3913,7 @@
       </p:sp>
       <p:sp>
         <p:nvSpPr>
-          <p:cNvPr id="9" name="TextBox 8"/>
+          <p:cNvPr id="10" name="TextBox 9"/>
           <p:cNvSpPr txBox="1"/>
           <p:nvPr/>
         </p:nvSpPr>
@@ -3923,7 +3981,7 @@
       </p:sp>
       <p:sp>
         <p:nvSpPr>
-          <p:cNvPr id="10" name="TextBox 9"/>
+          <p:cNvPr id="11" name="TextBox 10"/>
           <p:cNvSpPr txBox="1"/>
           <p:nvPr/>
         </p:nvSpPr>
@@ -3959,7 +4017,7 @@
       </p:sp>
       <p:sp>
         <p:nvSpPr>
-          <p:cNvPr id="11" name="Oval 10"/>
+          <p:cNvPr id="12" name="Oval 11"/>
           <p:cNvSpPr/>
           <p:nvPr/>
         </p:nvSpPr>
@@ -4004,7 +4062,7 @@
       </p:sp>
       <p:sp>
         <p:nvSpPr>
-          <p:cNvPr id="12" name="Oval 11"/>
+          <p:cNvPr id="13" name="Oval 12"/>
           <p:cNvSpPr/>
           <p:nvPr/>
         </p:nvSpPr>
@@ -4049,7 +4107,7 @@
       </p:sp>
       <p:sp>
         <p:nvSpPr>
-          <p:cNvPr id="13" name="Rounded Rectangle 12"/>
+          <p:cNvPr id="14" name="Rounded Rectangle 13"/>
           <p:cNvSpPr/>
           <p:nvPr/>
         </p:nvSpPr>
@@ -4092,7 +4150,7 @@
       </p:sp>
       <p:sp>
         <p:nvSpPr>
-          <p:cNvPr id="14" name="Oval 13"/>
+          <p:cNvPr id="15" name="Oval 14"/>
           <p:cNvSpPr/>
           <p:nvPr/>
         </p:nvSpPr>
@@ -4135,7 +4193,7 @@
       </p:sp>
       <p:sp>
         <p:nvSpPr>
-          <p:cNvPr id="15" name="Oval 14"/>
+          <p:cNvPr id="16" name="Oval 15"/>
           <p:cNvSpPr/>
           <p:nvPr/>
         </p:nvSpPr>
@@ -4178,7 +4236,7 @@
       </p:sp>
       <p:sp>
         <p:nvSpPr>
-          <p:cNvPr id="16" name="Oval 15"/>
+          <p:cNvPr id="17" name="Oval 16"/>
           <p:cNvSpPr/>
           <p:nvPr/>
         </p:nvSpPr>
@@ -4221,7 +4279,7 @@
       </p:sp>
       <p:sp>
         <p:nvSpPr>
-          <p:cNvPr id="17" name="Oval 16"/>
+          <p:cNvPr id="18" name="Oval 17"/>
           <p:cNvSpPr/>
           <p:nvPr/>
         </p:nvSpPr>
@@ -4264,7 +4322,7 @@
       </p:sp>
       <p:sp>
         <p:nvSpPr>
-          <p:cNvPr id="18" name="Oval 17"/>
+          <p:cNvPr id="19" name="Oval 18"/>
           <p:cNvSpPr/>
           <p:nvPr/>
         </p:nvSpPr>
@@ -4307,7 +4365,7 @@
       </p:sp>
       <p:sp>
         <p:nvSpPr>
-          <p:cNvPr id="19" name="Oval 18"/>
+          <p:cNvPr id="20" name="Oval 19"/>
           <p:cNvSpPr/>
           <p:nvPr/>
         </p:nvSpPr>
@@ -4350,7 +4408,7 @@
       </p:sp>
       <p:sp>
         <p:nvSpPr>
-          <p:cNvPr id="20" name="Oval 19"/>
+          <p:cNvPr id="21" name="Oval 20"/>
           <p:cNvSpPr/>
           <p:nvPr/>
         </p:nvSpPr>
@@ -4393,7 +4451,7 @@
       </p:sp>
       <p:sp>
         <p:nvSpPr>
-          <p:cNvPr id="21" name="Oval 20"/>
+          <p:cNvPr id="22" name="Oval 21"/>
           <p:cNvSpPr/>
           <p:nvPr/>
         </p:nvSpPr>
@@ -4436,7 +4494,7 @@
       </p:sp>
       <p:sp>
         <p:nvSpPr>
-          <p:cNvPr id="22" name="Oval 21"/>
+          <p:cNvPr id="23" name="Oval 22"/>
           <p:cNvSpPr/>
           <p:nvPr/>
         </p:nvSpPr>
@@ -4479,7 +4537,7 @@
       </p:sp>
       <p:sp>
         <p:nvSpPr>
-          <p:cNvPr id="23" name="Oval 22"/>
+          <p:cNvPr id="24" name="Oval 23"/>
           <p:cNvSpPr/>
           <p:nvPr/>
         </p:nvSpPr>
@@ -4522,7 +4580,7 @@
       </p:sp>
       <p:sp>
         <p:nvSpPr>
-          <p:cNvPr id="24" name="Oval 23"/>
+          <p:cNvPr id="25" name="Oval 24"/>
           <p:cNvSpPr/>
           <p:nvPr/>
         </p:nvSpPr>
@@ -4565,7 +4623,7 @@
       </p:sp>
       <p:sp>
         <p:nvSpPr>
-          <p:cNvPr id="25" name="Oval 24"/>
+          <p:cNvPr id="26" name="Oval 25"/>
           <p:cNvSpPr/>
           <p:nvPr/>
         </p:nvSpPr>
@@ -4608,7 +4666,7 @@
       </p:sp>
       <p:sp>
         <p:nvSpPr>
-          <p:cNvPr id="26" name="Oval 25"/>
+          <p:cNvPr id="27" name="Oval 26"/>
           <p:cNvSpPr/>
           <p:nvPr/>
         </p:nvSpPr>
@@ -4651,7 +4709,7 @@
       </p:sp>
       <p:sp>
         <p:nvSpPr>
-          <p:cNvPr id="27" name="Oval 26"/>
+          <p:cNvPr id="28" name="Oval 27"/>
           <p:cNvSpPr/>
           <p:nvPr/>
         </p:nvSpPr>
@@ -4694,7 +4752,7 @@
       </p:sp>
       <p:sp>
         <p:nvSpPr>
-          <p:cNvPr id="28" name="Oval 27"/>
+          <p:cNvPr id="29" name="Oval 28"/>
           <p:cNvSpPr/>
           <p:nvPr/>
         </p:nvSpPr>
@@ -4737,7 +4795,7 @@
       </p:sp>
       <p:sp>
         <p:nvSpPr>
-          <p:cNvPr id="29" name="Oval 28"/>
+          <p:cNvPr id="30" name="Oval 29"/>
           <p:cNvSpPr/>
           <p:nvPr/>
         </p:nvSpPr>
@@ -4780,7 +4838,7 @@
       </p:sp>
       <p:sp>
         <p:nvSpPr>
-          <p:cNvPr id="30" name="Rectangle 29"/>
+          <p:cNvPr id="31" name="Rectangle 30"/>
           <p:cNvSpPr/>
           <p:nvPr/>
         </p:nvSpPr>
@@ -4823,7 +4881,7 @@
       </p:sp>
       <p:sp>
         <p:nvSpPr>
-          <p:cNvPr id="31" name="TextBox 30"/>
+          <p:cNvPr id="32" name="TextBox 31"/>
           <p:cNvSpPr txBox="1"/>
           <p:nvPr/>
         </p:nvSpPr>
@@ -4859,7 +4917,7 @@
       </p:sp>
       <p:sp>
         <p:nvSpPr>
-          <p:cNvPr id="32" name="Rectangle 31"/>
+          <p:cNvPr id="33" name="Rectangle 32"/>
           <p:cNvSpPr/>
           <p:nvPr/>
         </p:nvSpPr>
@@ -4902,7 +4960,7 @@
       </p:sp>
       <p:sp>
         <p:nvSpPr>
-          <p:cNvPr id="33" name="TextBox 32"/>
+          <p:cNvPr id="34" name="TextBox 33"/>
           <p:cNvSpPr txBox="1"/>
           <p:nvPr/>
         </p:nvSpPr>
@@ -5015,8 +5073,8 @@
       </p:sp>
       <p:sp>
         <p:nvSpPr>
-          <p:cNvPr id="3" name="Rectangle 2"/>
-          <p:cNvSpPr/>
+          <p:cNvPr id="3" name="TextBox 2"/>
+          <p:cNvSpPr txBox="1"/>
           <p:nvPr/>
         </p:nvSpPr>
         <p:spPr>
@@ -5027,29 +5085,15 @@
           <a:prstGeom prst="rect">
             <a:avLst/>
           </a:prstGeom>
-          <a:solidFill>
-            <a:srgbClr val="BFC0BF"/>
-          </a:solidFill>
+          <a:noFill/>
           <a:ln>
             <a:noFill/>
           </a:ln>
         </p:spPr>
-        <p:style>
-          <a:lnRef idx="1">
-            <a:schemeClr val="accent1"/>
-          </a:lnRef>
-          <a:fillRef idx="3">
-            <a:schemeClr val="accent1"/>
-          </a:fillRef>
-          <a:effectRef idx="2">
-            <a:schemeClr val="accent1"/>
-          </a:effectRef>
-          <a:fontRef idx="minor">
-            <a:schemeClr val="lt1"/>
-          </a:fontRef>
-        </p:style>
-        <p:txBody>
-          <a:bodyPr rtlCol="0" anchor="ctr" wrap="square" lIns="0" rIns="0" tIns="0" bIns="0"/>
+        <p:txBody>
+          <a:bodyPr wrap="square" anchor="ctr" lIns="0" rIns="0" tIns="0" bIns="0">
+            <a:spAutoFit/>
+          </a:bodyPr>
           <a:lstStyle/>
           <a:p>
             <a:pPr algn="ctr">
@@ -5066,826 +5110,9 @@
           </a:p>
         </p:txBody>
       </p:sp>
-      <p:sp>
-        <p:nvSpPr>
-          <p:cNvPr id="4" name="Rectangle 3"/>
-          <p:cNvSpPr/>
-          <p:nvPr/>
-        </p:nvSpPr>
-        <p:spPr>
-          <a:xfrm>
-            <a:off x="0" y="6537960"/>
-            <a:ext cx="12191695" cy="320040"/>
-          </a:xfrm>
-          <a:prstGeom prst="rect">
-            <a:avLst/>
-          </a:prstGeom>
-          <a:solidFill>
-            <a:srgbClr val="006FC0"/>
-          </a:solidFill>
-          <a:ln>
-            <a:noFill/>
-          </a:ln>
-        </p:spPr>
-        <p:style>
-          <a:lnRef idx="1">
-            <a:schemeClr val="accent1"/>
-          </a:lnRef>
-          <a:fillRef idx="3">
-            <a:schemeClr val="accent1"/>
-          </a:fillRef>
-          <a:effectRef idx="2">
-            <a:schemeClr val="accent1"/>
-          </a:effectRef>
-          <a:fontRef idx="minor">
-            <a:schemeClr val="lt1"/>
-          </a:fontRef>
-        </p:style>
-        <p:txBody>
-          <a:bodyPr rtlCol="0" anchor="ctr" lIns="548640" rIns="548640"/>
-          <a:lstStyle/>
-          <a:p>
-            <a:pPr algn="ctr">
-              <a:defRPr sz="1100">
-                <a:solidFill>
-                  <a:srgbClr val="FFFFFF"/>
-                </a:solidFill>
-                <a:latin typeface="Arial"/>
-              </a:defRPr>
-            </a:pPr>
-            <a:r>
-              <a:t>@SIH Idea submission- Template</a:t>
-            </a:r>
-          </a:p>
-        </p:txBody>
-      </p:sp>
-      <p:sp>
-        <p:nvSpPr>
-          <p:cNvPr id="5" name="TextBox 4"/>
-          <p:cNvSpPr txBox="1"/>
-          <p:nvPr/>
-        </p:nvSpPr>
-        <p:spPr>
-          <a:xfrm>
-            <a:off x="11247120" y="6547104"/>
-            <a:ext cx="548640" cy="292608"/>
-          </a:xfrm>
-          <a:prstGeom prst="rect">
-            <a:avLst/>
-          </a:prstGeom>
-          <a:noFill/>
-        </p:spPr>
-        <p:txBody>
-          <a:bodyPr wrap="none">
-            <a:spAutoFit/>
-          </a:bodyPr>
-          <a:lstStyle/>
-          <a:p>
-            <a:pPr algn="r">
-              <a:defRPr sz="1100" b="1">
-                <a:solidFill>
-                  <a:srgbClr val="FFFFFF"/>
-                </a:solidFill>
-                <a:latin typeface="Arial"/>
-              </a:defRPr>
-            </a:pPr>
-            <a:r>
-              <a:t>3</a:t>
-            </a:r>
-          </a:p>
-        </p:txBody>
-      </p:sp>
-      <p:sp>
-        <p:nvSpPr>
-          <p:cNvPr id="6" name="TextBox 5"/>
-          <p:cNvSpPr txBox="1"/>
-          <p:nvPr/>
-        </p:nvSpPr>
-        <p:spPr>
-          <a:xfrm>
-            <a:off x="548640" y="1188720"/>
-            <a:ext cx="4206240" cy="411480"/>
-          </a:xfrm>
-          <a:prstGeom prst="rect">
-            <a:avLst/>
-          </a:prstGeom>
-          <a:noFill/>
-        </p:spPr>
-        <p:txBody>
-          <a:bodyPr wrap="square" lIns="0" tIns="0">
-            <a:spAutoFit/>
-          </a:bodyPr>
-          <a:lstStyle/>
-          <a:p>
-            <a:pPr>
-              <a:defRPr sz="1900" b="1" u="sng">
-                <a:solidFill>
-                  <a:srgbClr val="1F487C"/>
-                </a:solidFill>
-                <a:latin typeface="Arial"/>
-              </a:defRPr>
-            </a:pPr>
-            <a:r>
-              <a:t>System Workflow</a:t>
-            </a:r>
-          </a:p>
-        </p:txBody>
-      </p:sp>
-      <p:sp>
-        <p:nvSpPr>
-          <p:cNvPr id="7" name="Rounded Rectangle 6"/>
-          <p:cNvSpPr/>
-          <p:nvPr/>
-        </p:nvSpPr>
-        <p:spPr>
-          <a:xfrm>
-            <a:off x="548640" y="1691640"/>
-            <a:ext cx="4206240" cy="457200"/>
-          </a:xfrm>
-          <a:prstGeom prst="roundRect">
-            <a:avLst/>
-          </a:prstGeom>
-          <a:solidFill>
-            <a:srgbClr val="006FC0"/>
-          </a:solidFill>
-          <a:ln>
-            <a:noFill/>
-          </a:ln>
-        </p:spPr>
-        <p:style>
-          <a:lnRef idx="1">
-            <a:schemeClr val="accent1"/>
-          </a:lnRef>
-          <a:fillRef idx="3">
-            <a:schemeClr val="accent1"/>
-          </a:fillRef>
-          <a:effectRef idx="2">
-            <a:schemeClr val="accent1"/>
-          </a:effectRef>
-          <a:fontRef idx="minor">
-            <a:schemeClr val="lt1"/>
-          </a:fontRef>
-        </p:style>
-        <p:txBody>
-          <a:bodyPr rtlCol="0" anchor="ctr"/>
-          <a:lstStyle/>
-          <a:p>
-            <a:pPr algn="ctr">
-              <a:defRPr sz="1150" b="1">
-                <a:solidFill>
-                  <a:srgbClr val="FFFFFF"/>
-                </a:solidFill>
-                <a:latin typeface="Arial"/>
-              </a:defRPr>
-            </a:pPr>
-            <a:r>
-              <a:t>LiDAR Point Cloud</a:t>
-            </a:r>
-          </a:p>
-        </p:txBody>
-      </p:sp>
-      <p:sp>
-        <p:nvSpPr>
-          <p:cNvPr id="8" name="Down Arrow 7"/>
-          <p:cNvSpPr/>
-          <p:nvPr/>
-        </p:nvSpPr>
-        <p:spPr>
-          <a:xfrm>
-            <a:off x="2542032" y="2167128"/>
-            <a:ext cx="219456" cy="164592"/>
-          </a:xfrm>
-          <a:prstGeom prst="downArrow">
-            <a:avLst/>
-          </a:prstGeom>
-          <a:solidFill>
-            <a:srgbClr val="1E2760"/>
-          </a:solidFill>
-          <a:ln>
-            <a:noFill/>
-          </a:ln>
-        </p:spPr>
-        <p:style>
-          <a:lnRef idx="1">
-            <a:schemeClr val="accent1"/>
-          </a:lnRef>
-          <a:fillRef idx="3">
-            <a:schemeClr val="accent1"/>
-          </a:fillRef>
-          <a:effectRef idx="2">
-            <a:schemeClr val="accent1"/>
-          </a:effectRef>
-          <a:fontRef idx="minor">
-            <a:schemeClr val="lt1"/>
-          </a:fontRef>
-        </p:style>
-        <p:txBody>
-          <a:bodyPr rtlCol="0" anchor="ctr"/>
-          <a:lstStyle/>
-          <a:p>
-            <a:pPr algn="ctr"/>
-          </a:p>
-        </p:txBody>
-      </p:sp>
-      <p:sp>
-        <p:nvSpPr>
-          <p:cNvPr id="9" name="Rounded Rectangle 8"/>
-          <p:cNvSpPr/>
-          <p:nvPr/>
-        </p:nvSpPr>
-        <p:spPr>
-          <a:xfrm>
-            <a:off x="548640" y="2386584"/>
-            <a:ext cx="4206240" cy="457200"/>
-          </a:xfrm>
-          <a:prstGeom prst="roundRect">
-            <a:avLst/>
-          </a:prstGeom>
-          <a:solidFill>
-            <a:srgbClr val="006FC0"/>
-          </a:solidFill>
-          <a:ln>
-            <a:noFill/>
-          </a:ln>
-        </p:spPr>
-        <p:style>
-          <a:lnRef idx="1">
-            <a:schemeClr val="accent1"/>
-          </a:lnRef>
-          <a:fillRef idx="3">
-            <a:schemeClr val="accent1"/>
-          </a:fillRef>
-          <a:effectRef idx="2">
-            <a:schemeClr val="accent1"/>
-          </a:effectRef>
-          <a:fontRef idx="minor">
-            <a:schemeClr val="lt1"/>
-          </a:fontRef>
-        </p:style>
-        <p:txBody>
-          <a:bodyPr rtlCol="0" anchor="ctr"/>
-          <a:lstStyle/>
-          <a:p>
-            <a:pPr algn="ctr">
-              <a:defRPr sz="1150" b="1">
-                <a:solidFill>
-                  <a:srgbClr val="FFFFFF"/>
-                </a:solidFill>
-                <a:latin typeface="Arial"/>
-              </a:defRPr>
-            </a:pPr>
-            <a:r>
-              <a:t>Preprocessing &amp; Noise Removal</a:t>
-            </a:r>
-          </a:p>
-        </p:txBody>
-      </p:sp>
-      <p:sp>
-        <p:nvSpPr>
-          <p:cNvPr id="10" name="Down Arrow 9"/>
-          <p:cNvSpPr/>
-          <p:nvPr/>
-        </p:nvSpPr>
-        <p:spPr>
-          <a:xfrm>
-            <a:off x="2542032" y="2862072"/>
-            <a:ext cx="219456" cy="164592"/>
-          </a:xfrm>
-          <a:prstGeom prst="downArrow">
-            <a:avLst/>
-          </a:prstGeom>
-          <a:solidFill>
-            <a:srgbClr val="1E2760"/>
-          </a:solidFill>
-          <a:ln>
-            <a:noFill/>
-          </a:ln>
-        </p:spPr>
-        <p:style>
-          <a:lnRef idx="1">
-            <a:schemeClr val="accent1"/>
-          </a:lnRef>
-          <a:fillRef idx="3">
-            <a:schemeClr val="accent1"/>
-          </a:fillRef>
-          <a:effectRef idx="2">
-            <a:schemeClr val="accent1"/>
-          </a:effectRef>
-          <a:fontRef idx="minor">
-            <a:schemeClr val="lt1"/>
-          </a:fontRef>
-        </p:style>
-        <p:txBody>
-          <a:bodyPr rtlCol="0" anchor="ctr"/>
-          <a:lstStyle/>
-          <a:p>
-            <a:pPr algn="ctr"/>
-          </a:p>
-        </p:txBody>
-      </p:sp>
-      <p:sp>
-        <p:nvSpPr>
-          <p:cNvPr id="11" name="Rounded Rectangle 10"/>
-          <p:cNvSpPr/>
-          <p:nvPr/>
-        </p:nvSpPr>
-        <p:spPr>
-          <a:xfrm>
-            <a:off x="548640" y="3081528"/>
-            <a:ext cx="4206240" cy="457200"/>
-          </a:xfrm>
-          <a:prstGeom prst="roundRect">
-            <a:avLst/>
-          </a:prstGeom>
-          <a:solidFill>
-            <a:srgbClr val="006FC0"/>
-          </a:solidFill>
-          <a:ln>
-            <a:noFill/>
-          </a:ln>
-        </p:spPr>
-        <p:style>
-          <a:lnRef idx="1">
-            <a:schemeClr val="accent1"/>
-          </a:lnRef>
-          <a:fillRef idx="3">
-            <a:schemeClr val="accent1"/>
-          </a:fillRef>
-          <a:effectRef idx="2">
-            <a:schemeClr val="accent1"/>
-          </a:effectRef>
-          <a:fontRef idx="minor">
-            <a:schemeClr val="lt1"/>
-          </a:fontRef>
-        </p:style>
-        <p:txBody>
-          <a:bodyPr rtlCol="0" anchor="ctr"/>
-          <a:lstStyle/>
-          <a:p>
-            <a:pPr algn="ctr">
-              <a:defRPr sz="1150" b="1">
-                <a:solidFill>
-                  <a:srgbClr val="FFFFFF"/>
-                </a:solidFill>
-                <a:latin typeface="Arial"/>
-              </a:defRPr>
-            </a:pPr>
-            <a:r>
-              <a:t>Semantic Understanding</a:t>
-            </a:r>
-          </a:p>
-        </p:txBody>
-      </p:sp>
-      <p:sp>
-        <p:nvSpPr>
-          <p:cNvPr id="12" name="Down Arrow 11"/>
-          <p:cNvSpPr/>
-          <p:nvPr/>
-        </p:nvSpPr>
-        <p:spPr>
-          <a:xfrm>
-            <a:off x="2542032" y="3557016"/>
-            <a:ext cx="219456" cy="164592"/>
-          </a:xfrm>
-          <a:prstGeom prst="downArrow">
-            <a:avLst/>
-          </a:prstGeom>
-          <a:solidFill>
-            <a:srgbClr val="1E2760"/>
-          </a:solidFill>
-          <a:ln>
-            <a:noFill/>
-          </a:ln>
-        </p:spPr>
-        <p:style>
-          <a:lnRef idx="1">
-            <a:schemeClr val="accent1"/>
-          </a:lnRef>
-          <a:fillRef idx="3">
-            <a:schemeClr val="accent1"/>
-          </a:fillRef>
-          <a:effectRef idx="2">
-            <a:schemeClr val="accent1"/>
-          </a:effectRef>
-          <a:fontRef idx="minor">
-            <a:schemeClr val="lt1"/>
-          </a:fontRef>
-        </p:style>
-        <p:txBody>
-          <a:bodyPr rtlCol="0" anchor="ctr"/>
-          <a:lstStyle/>
-          <a:p>
-            <a:pPr algn="ctr"/>
-          </a:p>
-        </p:txBody>
-      </p:sp>
-      <p:sp>
-        <p:nvSpPr>
-          <p:cNvPr id="13" name="Rounded Rectangle 12"/>
-          <p:cNvSpPr/>
-          <p:nvPr/>
-        </p:nvSpPr>
-        <p:spPr>
-          <a:xfrm>
-            <a:off x="548640" y="3776472"/>
-            <a:ext cx="4206240" cy="457200"/>
-          </a:xfrm>
-          <a:prstGeom prst="roundRect">
-            <a:avLst/>
-          </a:prstGeom>
-          <a:solidFill>
-            <a:srgbClr val="1E2760"/>
-          </a:solidFill>
-          <a:ln>
-            <a:noFill/>
-          </a:ln>
-        </p:spPr>
-        <p:style>
-          <a:lnRef idx="1">
-            <a:schemeClr val="accent1"/>
-          </a:lnRef>
-          <a:fillRef idx="3">
-            <a:schemeClr val="accent1"/>
-          </a:fillRef>
-          <a:effectRef idx="2">
-            <a:schemeClr val="accent1"/>
-          </a:effectRef>
-          <a:fontRef idx="minor">
-            <a:schemeClr val="lt1"/>
-          </a:fontRef>
-        </p:style>
-        <p:txBody>
-          <a:bodyPr rtlCol="0" anchor="ctr"/>
-          <a:lstStyle/>
-          <a:p>
-            <a:pPr algn="ctr">
-              <a:defRPr sz="1200" b="1">
-                <a:solidFill>
-                  <a:srgbClr val="FFFFFF"/>
-                </a:solidFill>
-                <a:latin typeface="Arial"/>
-              </a:defRPr>
-            </a:pPr>
-            <a:r>
-              <a:t>Foveated Adaptive Grid Generation</a:t>
-            </a:r>
-          </a:p>
-        </p:txBody>
-      </p:sp>
-      <p:sp>
-        <p:nvSpPr>
-          <p:cNvPr id="14" name="Down Arrow 13"/>
-          <p:cNvSpPr/>
-          <p:nvPr/>
-        </p:nvSpPr>
-        <p:spPr>
-          <a:xfrm>
-            <a:off x="2542032" y="4251960"/>
-            <a:ext cx="219456" cy="164592"/>
-          </a:xfrm>
-          <a:prstGeom prst="downArrow">
-            <a:avLst/>
-          </a:prstGeom>
-          <a:solidFill>
-            <a:srgbClr val="1E2760"/>
-          </a:solidFill>
-          <a:ln>
-            <a:noFill/>
-          </a:ln>
-        </p:spPr>
-        <p:style>
-          <a:lnRef idx="1">
-            <a:schemeClr val="accent1"/>
-          </a:lnRef>
-          <a:fillRef idx="3">
-            <a:schemeClr val="accent1"/>
-          </a:fillRef>
-          <a:effectRef idx="2">
-            <a:schemeClr val="accent1"/>
-          </a:effectRef>
-          <a:fontRef idx="minor">
-            <a:schemeClr val="lt1"/>
-          </a:fontRef>
-        </p:style>
-        <p:txBody>
-          <a:bodyPr rtlCol="0" anchor="ctr"/>
-          <a:lstStyle/>
-          <a:p>
-            <a:pPr algn="ctr"/>
-          </a:p>
-        </p:txBody>
-      </p:sp>
-      <p:sp>
-        <p:nvSpPr>
-          <p:cNvPr id="15" name="Rounded Rectangle 14"/>
-          <p:cNvSpPr/>
-          <p:nvPr/>
-        </p:nvSpPr>
-        <p:spPr>
-          <a:xfrm>
-            <a:off x="548640" y="4471416"/>
-            <a:ext cx="4206240" cy="457200"/>
-          </a:xfrm>
-          <a:prstGeom prst="roundRect">
-            <a:avLst/>
-          </a:prstGeom>
-          <a:solidFill>
-            <a:srgbClr val="006FC0"/>
-          </a:solidFill>
-          <a:ln>
-            <a:noFill/>
-          </a:ln>
-        </p:spPr>
-        <p:style>
-          <a:lnRef idx="1">
-            <a:schemeClr val="accent1"/>
-          </a:lnRef>
-          <a:fillRef idx="3">
-            <a:schemeClr val="accent1"/>
-          </a:fillRef>
-          <a:effectRef idx="2">
-            <a:schemeClr val="accent1"/>
-          </a:effectRef>
-          <a:fontRef idx="minor">
-            <a:schemeClr val="lt1"/>
-          </a:fontRef>
-        </p:style>
-        <p:txBody>
-          <a:bodyPr rtlCol="0" anchor="ctr"/>
-          <a:lstStyle/>
-          <a:p>
-            <a:pPr algn="ctr">
-              <a:defRPr sz="1150" b="1">
-                <a:solidFill>
-                  <a:srgbClr val="FFFFFF"/>
-                </a:solidFill>
-                <a:latin typeface="Arial"/>
-              </a:defRPr>
-            </a:pPr>
-            <a:r>
-              <a:t>2.5D Semantic Elevation Map</a:t>
-            </a:r>
-          </a:p>
-        </p:txBody>
-      </p:sp>
-      <p:sp>
-        <p:nvSpPr>
-          <p:cNvPr id="16" name="Down Arrow 15"/>
-          <p:cNvSpPr/>
-          <p:nvPr/>
-        </p:nvSpPr>
-        <p:spPr>
-          <a:xfrm>
-            <a:off x="2542032" y="4946904"/>
-            <a:ext cx="219456" cy="164592"/>
-          </a:xfrm>
-          <a:prstGeom prst="downArrow">
-            <a:avLst/>
-          </a:prstGeom>
-          <a:solidFill>
-            <a:srgbClr val="1E2760"/>
-          </a:solidFill>
-          <a:ln>
-            <a:noFill/>
-          </a:ln>
-        </p:spPr>
-        <p:style>
-          <a:lnRef idx="1">
-            <a:schemeClr val="accent1"/>
-          </a:lnRef>
-          <a:fillRef idx="3">
-            <a:schemeClr val="accent1"/>
-          </a:fillRef>
-          <a:effectRef idx="2">
-            <a:schemeClr val="accent1"/>
-          </a:effectRef>
-          <a:fontRef idx="minor">
-            <a:schemeClr val="lt1"/>
-          </a:fontRef>
-        </p:style>
-        <p:txBody>
-          <a:bodyPr rtlCol="0" anchor="ctr"/>
-          <a:lstStyle/>
-          <a:p>
-            <a:pPr algn="ctr"/>
-          </a:p>
-        </p:txBody>
-      </p:sp>
-      <p:sp>
-        <p:nvSpPr>
-          <p:cNvPr id="17" name="Rounded Rectangle 16"/>
-          <p:cNvSpPr/>
-          <p:nvPr/>
-        </p:nvSpPr>
-        <p:spPr>
-          <a:xfrm>
-            <a:off x="548640" y="5166360"/>
-            <a:ext cx="4206240" cy="457200"/>
-          </a:xfrm>
-          <a:prstGeom prst="roundRect">
-            <a:avLst/>
-          </a:prstGeom>
-          <a:solidFill>
-            <a:srgbClr val="006FC0"/>
-          </a:solidFill>
-          <a:ln>
-            <a:noFill/>
-          </a:ln>
-        </p:spPr>
-        <p:style>
-          <a:lnRef idx="1">
-            <a:schemeClr val="accent1"/>
-          </a:lnRef>
-          <a:fillRef idx="3">
-            <a:schemeClr val="accent1"/>
-          </a:fillRef>
-          <a:effectRef idx="2">
-            <a:schemeClr val="accent1"/>
-          </a:effectRef>
-          <a:fontRef idx="minor">
-            <a:schemeClr val="lt1"/>
-          </a:fontRef>
-        </p:style>
-        <p:txBody>
-          <a:bodyPr rtlCol="0" anchor="ctr"/>
-          <a:lstStyle/>
-          <a:p>
-            <a:pPr algn="ctr">
-              <a:defRPr sz="1150" b="1">
-                <a:solidFill>
-                  <a:srgbClr val="FFFFFF"/>
-                </a:solidFill>
-                <a:latin typeface="Arial"/>
-              </a:defRPr>
-            </a:pPr>
-            <a:r>
-              <a:t>Real-Time Visualization &amp; Navigation</a:t>
-            </a:r>
-          </a:p>
-        </p:txBody>
-      </p:sp>
-      <p:sp>
-        <p:nvSpPr>
-          <p:cNvPr id="18" name="TextBox 17"/>
-          <p:cNvSpPr txBox="1"/>
-          <p:nvPr/>
-        </p:nvSpPr>
-        <p:spPr>
-          <a:xfrm>
-            <a:off x="5120640" y="1188720"/>
-            <a:ext cx="6492240" cy="411480"/>
-          </a:xfrm>
-          <a:prstGeom prst="rect">
-            <a:avLst/>
-          </a:prstGeom>
-          <a:noFill/>
-        </p:spPr>
-        <p:txBody>
-          <a:bodyPr wrap="square" lIns="0" tIns="0">
-            <a:spAutoFit/>
-          </a:bodyPr>
-          <a:lstStyle/>
-          <a:p>
-            <a:pPr>
-              <a:defRPr sz="1900" b="1" u="sng">
-                <a:solidFill>
-                  <a:srgbClr val="1F487C"/>
-                </a:solidFill>
-                <a:latin typeface="Arial"/>
-              </a:defRPr>
-            </a:pPr>
-            <a:r>
-              <a:t>Technologies &amp; Implementation</a:t>
-            </a:r>
-          </a:p>
-        </p:txBody>
-      </p:sp>
-      <p:sp>
-        <p:nvSpPr>
-          <p:cNvPr id="19" name="TextBox 18"/>
-          <p:cNvSpPr txBox="1"/>
-          <p:nvPr/>
-        </p:nvSpPr>
-        <p:spPr>
-          <a:xfrm>
-            <a:off x="5120640" y="1645920"/>
-            <a:ext cx="6492240" cy="1280160"/>
-          </a:xfrm>
-          <a:prstGeom prst="rect">
-            <a:avLst/>
-          </a:prstGeom>
-          <a:noFill/>
-        </p:spPr>
-        <p:txBody>
-          <a:bodyPr wrap="square" lIns="0" tIns="0">
-            <a:spAutoFit/>
-          </a:bodyPr>
-          <a:lstStyle/>
-          <a:p>
-            <a:pPr>
-              <a:spcAft>
-                <a:spcPts val="200"/>
-              </a:spcAft>
-            </a:pPr>
-            <a:r>
-              <a:rPr sz="1150" b="1">
-                <a:solidFill>
-                  <a:srgbClr val="000000"/>
-                </a:solidFill>
-                <a:latin typeface="Arial"/>
-              </a:rPr>
-              <a:t>• Python, Open3D &amp; NumPy: </a:t>
-            </a:r>
-            <a:r>
-              <a:rPr sz="1150" b="0">
-                <a:solidFill>
-                  <a:srgbClr val="232323"/>
-                </a:solidFill>
-                <a:latin typeface="Arial"/>
-              </a:rPr>
-              <a:t>Point cloud preprocessing, voxelization &amp; spatial hashing.</a:t>
-            </a:r>
-          </a:p>
-          <a:p>
-            <a:pPr>
-              <a:spcAft>
-                <a:spcPts val="200"/>
-              </a:spcAft>
-            </a:pPr>
-            <a:r>
-              <a:rPr sz="1150" b="1">
-                <a:solidFill>
-                  <a:srgbClr val="000000"/>
-                </a:solidFill>
-                <a:latin typeface="Arial"/>
-              </a:rPr>
-              <a:t>• Deep Learning: </a:t>
-            </a:r>
-            <a:r>
-              <a:rPr sz="1150" b="0">
-                <a:solidFill>
-                  <a:srgbClr val="232323"/>
-                </a:solidFill>
-                <a:latin typeface="Arial"/>
-              </a:rPr>
-              <a:t>Semantic terrain classification (Ground, Static Obstacles, Dynamic Vehicles).</a:t>
-            </a:r>
-          </a:p>
-          <a:p>
-            <a:pPr>
-              <a:spcAft>
-                <a:spcPts val="200"/>
-              </a:spcAft>
-            </a:pPr>
-            <a:r>
-              <a:rPr sz="1150" b="1">
-                <a:solidFill>
-                  <a:srgbClr val="000000"/>
-                </a:solidFill>
-                <a:latin typeface="Arial"/>
-              </a:rPr>
-              <a:t>• A* Search &amp; Pure Pursuit: </a:t>
-            </a:r>
-            <a:r>
-              <a:rPr sz="1150" b="0">
-                <a:solidFill>
-                  <a:srgbClr val="232323"/>
-                </a:solidFill>
-                <a:latin typeface="Arial"/>
-              </a:rPr>
-              <a:t>Collision-free path planning &amp; smooth 10 Hz vehicle steering kinematics.</a:t>
-            </a:r>
-          </a:p>
-          <a:p>
-            <a:pPr>
-              <a:spcAft>
-                <a:spcPts val="200"/>
-              </a:spcAft>
-            </a:pPr>
-            <a:r>
-              <a:rPr sz="1150" b="1">
-                <a:solidFill>
-                  <a:srgbClr val="000000"/>
-                </a:solidFill>
-                <a:latin typeface="Arial"/>
-              </a:rPr>
-              <a:t>• Interactive Web Dashboard: </a:t>
-            </a:r>
-            <a:r>
-              <a:rPr sz="1150" b="0">
-                <a:solidFill>
-                  <a:srgbClr val="232323"/>
-                </a:solidFill>
-                <a:latin typeface="Arial"/>
-              </a:rPr>
-              <a:t>Flask REST API, 60 FPS HTML5 Canvas with moving foveation bubble.</a:t>
-            </a:r>
-          </a:p>
-        </p:txBody>
-      </p:sp>
       <p:pic>
         <p:nvPicPr>
-          <p:cNvPr id="20" name="Picture 19" descr="slide3_key_plots.png"/>
+          <p:cNvPr id="4" name="Picture 3" descr="sih_logo.png"/>
           <p:cNvPicPr>
             <a:picLocks noChangeAspect="1"/>
           </p:cNvPicPr>
@@ -5899,8 +5126,849 @@
         </p:blipFill>
         <p:spPr>
           <a:xfrm>
+            <a:off x="10241280" y="164592"/>
+            <a:ext cx="1508760" cy="712897"/>
+          </a:xfrm>
+          <a:prstGeom prst="rect">
+            <a:avLst/>
+          </a:prstGeom>
+        </p:spPr>
+      </p:pic>
+      <p:sp>
+        <p:nvSpPr>
+          <p:cNvPr id="5" name="Rectangle 4"/>
+          <p:cNvSpPr/>
+          <p:nvPr/>
+        </p:nvSpPr>
+        <p:spPr>
+          <a:xfrm>
+            <a:off x="0" y="6537960"/>
+            <a:ext cx="12191695" cy="320040"/>
+          </a:xfrm>
+          <a:prstGeom prst="rect">
+            <a:avLst/>
+          </a:prstGeom>
+          <a:solidFill>
+            <a:srgbClr val="006FC0"/>
+          </a:solidFill>
+          <a:ln>
+            <a:noFill/>
+          </a:ln>
+        </p:spPr>
+        <p:style>
+          <a:lnRef idx="1">
+            <a:schemeClr val="accent1"/>
+          </a:lnRef>
+          <a:fillRef idx="3">
+            <a:schemeClr val="accent1"/>
+          </a:fillRef>
+          <a:effectRef idx="2">
+            <a:schemeClr val="accent1"/>
+          </a:effectRef>
+          <a:fontRef idx="minor">
+            <a:schemeClr val="lt1"/>
+          </a:fontRef>
+        </p:style>
+        <p:txBody>
+          <a:bodyPr rtlCol="0" anchor="ctr" lIns="548640" rIns="548640"/>
+          <a:lstStyle/>
+          <a:p>
+            <a:pPr algn="ctr">
+              <a:defRPr sz="1100">
+                <a:solidFill>
+                  <a:srgbClr val="FFFFFF"/>
+                </a:solidFill>
+                <a:latin typeface="Arial"/>
+              </a:defRPr>
+            </a:pPr>
+            <a:r>
+              <a:t>@SIH Idea submission- Template</a:t>
+            </a:r>
+          </a:p>
+        </p:txBody>
+      </p:sp>
+      <p:sp>
+        <p:nvSpPr>
+          <p:cNvPr id="6" name="TextBox 5"/>
+          <p:cNvSpPr txBox="1"/>
+          <p:nvPr/>
+        </p:nvSpPr>
+        <p:spPr>
+          <a:xfrm>
+            <a:off x="11247120" y="6547104"/>
+            <a:ext cx="548640" cy="292608"/>
+          </a:xfrm>
+          <a:prstGeom prst="rect">
+            <a:avLst/>
+          </a:prstGeom>
+          <a:noFill/>
+        </p:spPr>
+        <p:txBody>
+          <a:bodyPr wrap="none">
+            <a:spAutoFit/>
+          </a:bodyPr>
+          <a:lstStyle/>
+          <a:p>
+            <a:pPr algn="r">
+              <a:defRPr sz="1100" b="1">
+                <a:solidFill>
+                  <a:srgbClr val="FFFFFF"/>
+                </a:solidFill>
+                <a:latin typeface="Arial"/>
+              </a:defRPr>
+            </a:pPr>
+            <a:r>
+              <a:t>3</a:t>
+            </a:r>
+          </a:p>
+        </p:txBody>
+      </p:sp>
+      <p:sp>
+        <p:nvSpPr>
+          <p:cNvPr id="7" name="TextBox 6"/>
+          <p:cNvSpPr txBox="1"/>
+          <p:nvPr/>
+        </p:nvSpPr>
+        <p:spPr>
+          <a:xfrm>
+            <a:off x="548640" y="1188720"/>
+            <a:ext cx="4206240" cy="411480"/>
+          </a:xfrm>
+          <a:prstGeom prst="rect">
+            <a:avLst/>
+          </a:prstGeom>
+          <a:noFill/>
+        </p:spPr>
+        <p:txBody>
+          <a:bodyPr wrap="square" lIns="0" tIns="0">
+            <a:spAutoFit/>
+          </a:bodyPr>
+          <a:lstStyle/>
+          <a:p>
+            <a:pPr>
+              <a:defRPr sz="1900" b="1" u="sng">
+                <a:solidFill>
+                  <a:srgbClr val="1F487C"/>
+                </a:solidFill>
+                <a:latin typeface="Arial"/>
+              </a:defRPr>
+            </a:pPr>
+            <a:r>
+              <a:t>System Workflow</a:t>
+            </a:r>
+          </a:p>
+        </p:txBody>
+      </p:sp>
+      <p:sp>
+        <p:nvSpPr>
+          <p:cNvPr id="8" name="Rounded Rectangle 7"/>
+          <p:cNvSpPr/>
+          <p:nvPr/>
+        </p:nvSpPr>
+        <p:spPr>
+          <a:xfrm>
+            <a:off x="548640" y="1691640"/>
+            <a:ext cx="4206240" cy="457200"/>
+          </a:xfrm>
+          <a:prstGeom prst="roundRect">
+            <a:avLst/>
+          </a:prstGeom>
+          <a:solidFill>
+            <a:srgbClr val="006FC0"/>
+          </a:solidFill>
+          <a:ln>
+            <a:noFill/>
+          </a:ln>
+        </p:spPr>
+        <p:style>
+          <a:lnRef idx="1">
+            <a:schemeClr val="accent1"/>
+          </a:lnRef>
+          <a:fillRef idx="3">
+            <a:schemeClr val="accent1"/>
+          </a:fillRef>
+          <a:effectRef idx="2">
+            <a:schemeClr val="accent1"/>
+          </a:effectRef>
+          <a:fontRef idx="minor">
+            <a:schemeClr val="lt1"/>
+          </a:fontRef>
+        </p:style>
+        <p:txBody>
+          <a:bodyPr rtlCol="0" anchor="ctr"/>
+          <a:lstStyle/>
+          <a:p>
+            <a:pPr algn="ctr">
+              <a:defRPr sz="1150" b="1">
+                <a:solidFill>
+                  <a:srgbClr val="FFFFFF"/>
+                </a:solidFill>
+                <a:latin typeface="Arial"/>
+              </a:defRPr>
+            </a:pPr>
+            <a:r>
+              <a:t>LiDAR Point Cloud</a:t>
+            </a:r>
+          </a:p>
+        </p:txBody>
+      </p:sp>
+      <p:sp>
+        <p:nvSpPr>
+          <p:cNvPr id="9" name="Down Arrow 8"/>
+          <p:cNvSpPr/>
+          <p:nvPr/>
+        </p:nvSpPr>
+        <p:spPr>
+          <a:xfrm>
+            <a:off x="2542032" y="2167128"/>
+            <a:ext cx="219456" cy="164592"/>
+          </a:xfrm>
+          <a:prstGeom prst="downArrow">
+            <a:avLst/>
+          </a:prstGeom>
+          <a:solidFill>
+            <a:srgbClr val="1E2760"/>
+          </a:solidFill>
+          <a:ln>
+            <a:noFill/>
+          </a:ln>
+        </p:spPr>
+        <p:style>
+          <a:lnRef idx="1">
+            <a:schemeClr val="accent1"/>
+          </a:lnRef>
+          <a:fillRef idx="3">
+            <a:schemeClr val="accent1"/>
+          </a:fillRef>
+          <a:effectRef idx="2">
+            <a:schemeClr val="accent1"/>
+          </a:effectRef>
+          <a:fontRef idx="minor">
+            <a:schemeClr val="lt1"/>
+          </a:fontRef>
+        </p:style>
+        <p:txBody>
+          <a:bodyPr rtlCol="0" anchor="ctr"/>
+          <a:lstStyle/>
+          <a:p>
+            <a:pPr algn="ctr"/>
+          </a:p>
+        </p:txBody>
+      </p:sp>
+      <p:sp>
+        <p:nvSpPr>
+          <p:cNvPr id="10" name="Rounded Rectangle 9"/>
+          <p:cNvSpPr/>
+          <p:nvPr/>
+        </p:nvSpPr>
+        <p:spPr>
+          <a:xfrm>
+            <a:off x="548640" y="2386584"/>
+            <a:ext cx="4206240" cy="457200"/>
+          </a:xfrm>
+          <a:prstGeom prst="roundRect">
+            <a:avLst/>
+          </a:prstGeom>
+          <a:solidFill>
+            <a:srgbClr val="006FC0"/>
+          </a:solidFill>
+          <a:ln>
+            <a:noFill/>
+          </a:ln>
+        </p:spPr>
+        <p:style>
+          <a:lnRef idx="1">
+            <a:schemeClr val="accent1"/>
+          </a:lnRef>
+          <a:fillRef idx="3">
+            <a:schemeClr val="accent1"/>
+          </a:fillRef>
+          <a:effectRef idx="2">
+            <a:schemeClr val="accent1"/>
+          </a:effectRef>
+          <a:fontRef idx="minor">
+            <a:schemeClr val="lt1"/>
+          </a:fontRef>
+        </p:style>
+        <p:txBody>
+          <a:bodyPr rtlCol="0" anchor="ctr"/>
+          <a:lstStyle/>
+          <a:p>
+            <a:pPr algn="ctr">
+              <a:defRPr sz="1150" b="1">
+                <a:solidFill>
+                  <a:srgbClr val="FFFFFF"/>
+                </a:solidFill>
+                <a:latin typeface="Arial"/>
+              </a:defRPr>
+            </a:pPr>
+            <a:r>
+              <a:t>Preprocessing &amp; Noise Removal</a:t>
+            </a:r>
+          </a:p>
+        </p:txBody>
+      </p:sp>
+      <p:sp>
+        <p:nvSpPr>
+          <p:cNvPr id="11" name="Down Arrow 10"/>
+          <p:cNvSpPr/>
+          <p:nvPr/>
+        </p:nvSpPr>
+        <p:spPr>
+          <a:xfrm>
+            <a:off x="2542032" y="2862072"/>
+            <a:ext cx="219456" cy="164592"/>
+          </a:xfrm>
+          <a:prstGeom prst="downArrow">
+            <a:avLst/>
+          </a:prstGeom>
+          <a:solidFill>
+            <a:srgbClr val="1E2760"/>
+          </a:solidFill>
+          <a:ln>
+            <a:noFill/>
+          </a:ln>
+        </p:spPr>
+        <p:style>
+          <a:lnRef idx="1">
+            <a:schemeClr val="accent1"/>
+          </a:lnRef>
+          <a:fillRef idx="3">
+            <a:schemeClr val="accent1"/>
+          </a:fillRef>
+          <a:effectRef idx="2">
+            <a:schemeClr val="accent1"/>
+          </a:effectRef>
+          <a:fontRef idx="minor">
+            <a:schemeClr val="lt1"/>
+          </a:fontRef>
+        </p:style>
+        <p:txBody>
+          <a:bodyPr rtlCol="0" anchor="ctr"/>
+          <a:lstStyle/>
+          <a:p>
+            <a:pPr algn="ctr"/>
+          </a:p>
+        </p:txBody>
+      </p:sp>
+      <p:sp>
+        <p:nvSpPr>
+          <p:cNvPr id="12" name="Rounded Rectangle 11"/>
+          <p:cNvSpPr/>
+          <p:nvPr/>
+        </p:nvSpPr>
+        <p:spPr>
+          <a:xfrm>
+            <a:off x="548640" y="3081528"/>
+            <a:ext cx="4206240" cy="457200"/>
+          </a:xfrm>
+          <a:prstGeom prst="roundRect">
+            <a:avLst/>
+          </a:prstGeom>
+          <a:solidFill>
+            <a:srgbClr val="006FC0"/>
+          </a:solidFill>
+          <a:ln>
+            <a:noFill/>
+          </a:ln>
+        </p:spPr>
+        <p:style>
+          <a:lnRef idx="1">
+            <a:schemeClr val="accent1"/>
+          </a:lnRef>
+          <a:fillRef idx="3">
+            <a:schemeClr val="accent1"/>
+          </a:fillRef>
+          <a:effectRef idx="2">
+            <a:schemeClr val="accent1"/>
+          </a:effectRef>
+          <a:fontRef idx="minor">
+            <a:schemeClr val="lt1"/>
+          </a:fontRef>
+        </p:style>
+        <p:txBody>
+          <a:bodyPr rtlCol="0" anchor="ctr"/>
+          <a:lstStyle/>
+          <a:p>
+            <a:pPr algn="ctr">
+              <a:defRPr sz="1150" b="1">
+                <a:solidFill>
+                  <a:srgbClr val="FFFFFF"/>
+                </a:solidFill>
+                <a:latin typeface="Arial"/>
+              </a:defRPr>
+            </a:pPr>
+            <a:r>
+              <a:t>Semantic Understanding</a:t>
+            </a:r>
+          </a:p>
+        </p:txBody>
+      </p:sp>
+      <p:sp>
+        <p:nvSpPr>
+          <p:cNvPr id="13" name="Down Arrow 12"/>
+          <p:cNvSpPr/>
+          <p:nvPr/>
+        </p:nvSpPr>
+        <p:spPr>
+          <a:xfrm>
+            <a:off x="2542032" y="3557016"/>
+            <a:ext cx="219456" cy="164592"/>
+          </a:xfrm>
+          <a:prstGeom prst="downArrow">
+            <a:avLst/>
+          </a:prstGeom>
+          <a:solidFill>
+            <a:srgbClr val="1E2760"/>
+          </a:solidFill>
+          <a:ln>
+            <a:noFill/>
+          </a:ln>
+        </p:spPr>
+        <p:style>
+          <a:lnRef idx="1">
+            <a:schemeClr val="accent1"/>
+          </a:lnRef>
+          <a:fillRef idx="3">
+            <a:schemeClr val="accent1"/>
+          </a:fillRef>
+          <a:effectRef idx="2">
+            <a:schemeClr val="accent1"/>
+          </a:effectRef>
+          <a:fontRef idx="minor">
+            <a:schemeClr val="lt1"/>
+          </a:fontRef>
+        </p:style>
+        <p:txBody>
+          <a:bodyPr rtlCol="0" anchor="ctr"/>
+          <a:lstStyle/>
+          <a:p>
+            <a:pPr algn="ctr"/>
+          </a:p>
+        </p:txBody>
+      </p:sp>
+      <p:sp>
+        <p:nvSpPr>
+          <p:cNvPr id="14" name="Rounded Rectangle 13"/>
+          <p:cNvSpPr/>
+          <p:nvPr/>
+        </p:nvSpPr>
+        <p:spPr>
+          <a:xfrm>
+            <a:off x="548640" y="3776472"/>
+            <a:ext cx="4206240" cy="457200"/>
+          </a:xfrm>
+          <a:prstGeom prst="roundRect">
+            <a:avLst/>
+          </a:prstGeom>
+          <a:solidFill>
+            <a:srgbClr val="1E2760"/>
+          </a:solidFill>
+          <a:ln>
+            <a:noFill/>
+          </a:ln>
+        </p:spPr>
+        <p:style>
+          <a:lnRef idx="1">
+            <a:schemeClr val="accent1"/>
+          </a:lnRef>
+          <a:fillRef idx="3">
+            <a:schemeClr val="accent1"/>
+          </a:fillRef>
+          <a:effectRef idx="2">
+            <a:schemeClr val="accent1"/>
+          </a:effectRef>
+          <a:fontRef idx="minor">
+            <a:schemeClr val="lt1"/>
+          </a:fontRef>
+        </p:style>
+        <p:txBody>
+          <a:bodyPr rtlCol="0" anchor="ctr"/>
+          <a:lstStyle/>
+          <a:p>
+            <a:pPr algn="ctr">
+              <a:defRPr sz="1200" b="1">
+                <a:solidFill>
+                  <a:srgbClr val="FFFFFF"/>
+                </a:solidFill>
+                <a:latin typeface="Arial"/>
+              </a:defRPr>
+            </a:pPr>
+            <a:r>
+              <a:t>Foveated Adaptive Grid Generation</a:t>
+            </a:r>
+          </a:p>
+        </p:txBody>
+      </p:sp>
+      <p:sp>
+        <p:nvSpPr>
+          <p:cNvPr id="15" name="Down Arrow 14"/>
+          <p:cNvSpPr/>
+          <p:nvPr/>
+        </p:nvSpPr>
+        <p:spPr>
+          <a:xfrm>
+            <a:off x="2542032" y="4251960"/>
+            <a:ext cx="219456" cy="164592"/>
+          </a:xfrm>
+          <a:prstGeom prst="downArrow">
+            <a:avLst/>
+          </a:prstGeom>
+          <a:solidFill>
+            <a:srgbClr val="1E2760"/>
+          </a:solidFill>
+          <a:ln>
+            <a:noFill/>
+          </a:ln>
+        </p:spPr>
+        <p:style>
+          <a:lnRef idx="1">
+            <a:schemeClr val="accent1"/>
+          </a:lnRef>
+          <a:fillRef idx="3">
+            <a:schemeClr val="accent1"/>
+          </a:fillRef>
+          <a:effectRef idx="2">
+            <a:schemeClr val="accent1"/>
+          </a:effectRef>
+          <a:fontRef idx="minor">
+            <a:schemeClr val="lt1"/>
+          </a:fontRef>
+        </p:style>
+        <p:txBody>
+          <a:bodyPr rtlCol="0" anchor="ctr"/>
+          <a:lstStyle/>
+          <a:p>
+            <a:pPr algn="ctr"/>
+          </a:p>
+        </p:txBody>
+      </p:sp>
+      <p:sp>
+        <p:nvSpPr>
+          <p:cNvPr id="16" name="Rounded Rectangle 15"/>
+          <p:cNvSpPr/>
+          <p:nvPr/>
+        </p:nvSpPr>
+        <p:spPr>
+          <a:xfrm>
+            <a:off x="548640" y="4471416"/>
+            <a:ext cx="4206240" cy="457200"/>
+          </a:xfrm>
+          <a:prstGeom prst="roundRect">
+            <a:avLst/>
+          </a:prstGeom>
+          <a:solidFill>
+            <a:srgbClr val="006FC0"/>
+          </a:solidFill>
+          <a:ln>
+            <a:noFill/>
+          </a:ln>
+        </p:spPr>
+        <p:style>
+          <a:lnRef idx="1">
+            <a:schemeClr val="accent1"/>
+          </a:lnRef>
+          <a:fillRef idx="3">
+            <a:schemeClr val="accent1"/>
+          </a:fillRef>
+          <a:effectRef idx="2">
+            <a:schemeClr val="accent1"/>
+          </a:effectRef>
+          <a:fontRef idx="minor">
+            <a:schemeClr val="lt1"/>
+          </a:fontRef>
+        </p:style>
+        <p:txBody>
+          <a:bodyPr rtlCol="0" anchor="ctr"/>
+          <a:lstStyle/>
+          <a:p>
+            <a:pPr algn="ctr">
+              <a:defRPr sz="1150" b="1">
+                <a:solidFill>
+                  <a:srgbClr val="FFFFFF"/>
+                </a:solidFill>
+                <a:latin typeface="Arial"/>
+              </a:defRPr>
+            </a:pPr>
+            <a:r>
+              <a:t>2.5D Semantic Elevation Map</a:t>
+            </a:r>
+          </a:p>
+        </p:txBody>
+      </p:sp>
+      <p:sp>
+        <p:nvSpPr>
+          <p:cNvPr id="17" name="Down Arrow 16"/>
+          <p:cNvSpPr/>
+          <p:nvPr/>
+        </p:nvSpPr>
+        <p:spPr>
+          <a:xfrm>
+            <a:off x="2542032" y="4946904"/>
+            <a:ext cx="219456" cy="164592"/>
+          </a:xfrm>
+          <a:prstGeom prst="downArrow">
+            <a:avLst/>
+          </a:prstGeom>
+          <a:solidFill>
+            <a:srgbClr val="1E2760"/>
+          </a:solidFill>
+          <a:ln>
+            <a:noFill/>
+          </a:ln>
+        </p:spPr>
+        <p:style>
+          <a:lnRef idx="1">
+            <a:schemeClr val="accent1"/>
+          </a:lnRef>
+          <a:fillRef idx="3">
+            <a:schemeClr val="accent1"/>
+          </a:fillRef>
+          <a:effectRef idx="2">
+            <a:schemeClr val="accent1"/>
+          </a:effectRef>
+          <a:fontRef idx="minor">
+            <a:schemeClr val="lt1"/>
+          </a:fontRef>
+        </p:style>
+        <p:txBody>
+          <a:bodyPr rtlCol="0" anchor="ctr"/>
+          <a:lstStyle/>
+          <a:p>
+            <a:pPr algn="ctr"/>
+          </a:p>
+        </p:txBody>
+      </p:sp>
+      <p:sp>
+        <p:nvSpPr>
+          <p:cNvPr id="18" name="Rounded Rectangle 17"/>
+          <p:cNvSpPr/>
+          <p:nvPr/>
+        </p:nvSpPr>
+        <p:spPr>
+          <a:xfrm>
+            <a:off x="548640" y="5166360"/>
+            <a:ext cx="4206240" cy="457200"/>
+          </a:xfrm>
+          <a:prstGeom prst="roundRect">
+            <a:avLst/>
+          </a:prstGeom>
+          <a:solidFill>
+            <a:srgbClr val="006FC0"/>
+          </a:solidFill>
+          <a:ln>
+            <a:noFill/>
+          </a:ln>
+        </p:spPr>
+        <p:style>
+          <a:lnRef idx="1">
+            <a:schemeClr val="accent1"/>
+          </a:lnRef>
+          <a:fillRef idx="3">
+            <a:schemeClr val="accent1"/>
+          </a:fillRef>
+          <a:effectRef idx="2">
+            <a:schemeClr val="accent1"/>
+          </a:effectRef>
+          <a:fontRef idx="minor">
+            <a:schemeClr val="lt1"/>
+          </a:fontRef>
+        </p:style>
+        <p:txBody>
+          <a:bodyPr rtlCol="0" anchor="ctr"/>
+          <a:lstStyle/>
+          <a:p>
+            <a:pPr algn="ctr">
+              <a:defRPr sz="1150" b="1">
+                <a:solidFill>
+                  <a:srgbClr val="FFFFFF"/>
+                </a:solidFill>
+                <a:latin typeface="Arial"/>
+              </a:defRPr>
+            </a:pPr>
+            <a:r>
+              <a:t>Real-Time Visualization &amp; Navigation</a:t>
+            </a:r>
+          </a:p>
+        </p:txBody>
+      </p:sp>
+      <p:sp>
+        <p:nvSpPr>
+          <p:cNvPr id="19" name="TextBox 18"/>
+          <p:cNvSpPr txBox="1"/>
+          <p:nvPr/>
+        </p:nvSpPr>
+        <p:spPr>
+          <a:xfrm>
+            <a:off x="5120640" y="1188720"/>
+            <a:ext cx="6492240" cy="411480"/>
+          </a:xfrm>
+          <a:prstGeom prst="rect">
+            <a:avLst/>
+          </a:prstGeom>
+          <a:noFill/>
+        </p:spPr>
+        <p:txBody>
+          <a:bodyPr wrap="square" lIns="0" tIns="0">
+            <a:spAutoFit/>
+          </a:bodyPr>
+          <a:lstStyle/>
+          <a:p>
+            <a:pPr>
+              <a:defRPr sz="1900" b="1" u="sng">
+                <a:solidFill>
+                  <a:srgbClr val="1F487C"/>
+                </a:solidFill>
+                <a:latin typeface="Arial"/>
+              </a:defRPr>
+            </a:pPr>
+            <a:r>
+              <a:t>Technologies &amp; Implementation</a:t>
+            </a:r>
+          </a:p>
+        </p:txBody>
+      </p:sp>
+      <p:sp>
+        <p:nvSpPr>
+          <p:cNvPr id="20" name="TextBox 19"/>
+          <p:cNvSpPr txBox="1"/>
+          <p:nvPr/>
+        </p:nvSpPr>
+        <p:spPr>
+          <a:xfrm>
+            <a:off x="5120640" y="1645920"/>
+            <a:ext cx="6492240" cy="1280160"/>
+          </a:xfrm>
+          <a:prstGeom prst="rect">
+            <a:avLst/>
+          </a:prstGeom>
+          <a:noFill/>
+        </p:spPr>
+        <p:txBody>
+          <a:bodyPr wrap="square" lIns="0" tIns="0">
+            <a:spAutoFit/>
+          </a:bodyPr>
+          <a:lstStyle/>
+          <a:p>
+            <a:pPr>
+              <a:spcAft>
+                <a:spcPts val="200"/>
+              </a:spcAft>
+            </a:pPr>
+            <a:r>
+              <a:rPr sz="1150" b="1">
+                <a:solidFill>
+                  <a:srgbClr val="000000"/>
+                </a:solidFill>
+                <a:latin typeface="Arial"/>
+              </a:rPr>
+              <a:t>• Python, Open3D &amp; NumPy: </a:t>
+            </a:r>
+            <a:r>
+              <a:rPr sz="1150" b="0">
+                <a:solidFill>
+                  <a:srgbClr val="232323"/>
+                </a:solidFill>
+                <a:latin typeface="Arial"/>
+              </a:rPr>
+              <a:t>Point cloud preprocessing, voxelization &amp; spatial hashing.</a:t>
+            </a:r>
+          </a:p>
+          <a:p>
+            <a:pPr>
+              <a:spcAft>
+                <a:spcPts val="200"/>
+              </a:spcAft>
+            </a:pPr>
+            <a:r>
+              <a:rPr sz="1150" b="1">
+                <a:solidFill>
+                  <a:srgbClr val="000000"/>
+                </a:solidFill>
+                <a:latin typeface="Arial"/>
+              </a:rPr>
+              <a:t>• Deep Learning: </a:t>
+            </a:r>
+            <a:r>
+              <a:rPr sz="1150" b="0">
+                <a:solidFill>
+                  <a:srgbClr val="232323"/>
+                </a:solidFill>
+                <a:latin typeface="Arial"/>
+              </a:rPr>
+              <a:t>Semantic terrain classification (Ground, Static Obstacles, Dynamic Vehicles).</a:t>
+            </a:r>
+          </a:p>
+          <a:p>
+            <a:pPr>
+              <a:spcAft>
+                <a:spcPts val="200"/>
+              </a:spcAft>
+            </a:pPr>
+            <a:r>
+              <a:rPr sz="1150" b="1">
+                <a:solidFill>
+                  <a:srgbClr val="000000"/>
+                </a:solidFill>
+                <a:latin typeface="Arial"/>
+              </a:rPr>
+              <a:t>• A* Search &amp; Pure Pursuit: </a:t>
+            </a:r>
+            <a:r>
+              <a:rPr sz="1150" b="0">
+                <a:solidFill>
+                  <a:srgbClr val="232323"/>
+                </a:solidFill>
+                <a:latin typeface="Arial"/>
+              </a:rPr>
+              <a:t>Collision-free path planning &amp; smooth 10 Hz vehicle steering kinematics.</a:t>
+            </a:r>
+          </a:p>
+          <a:p>
+            <a:pPr>
+              <a:spcAft>
+                <a:spcPts val="200"/>
+              </a:spcAft>
+            </a:pPr>
+            <a:r>
+              <a:rPr sz="1150" b="1">
+                <a:solidFill>
+                  <a:srgbClr val="000000"/>
+                </a:solidFill>
+                <a:latin typeface="Arial"/>
+              </a:rPr>
+              <a:t>• Interactive Web Dashboard: </a:t>
+            </a:r>
+            <a:r>
+              <a:rPr sz="1150" b="0">
+                <a:solidFill>
+                  <a:srgbClr val="232323"/>
+                </a:solidFill>
+                <a:latin typeface="Arial"/>
+              </a:rPr>
+              <a:t>Flask REST API, 60 FPS HTML5 Canvas with moving foveation bubble.</a:t>
+            </a:r>
+          </a:p>
+        </p:txBody>
+      </p:sp>
+      <p:pic>
+        <p:nvPicPr>
+          <p:cNvPr id="21" name="Picture 20" descr="slide3_key_plots.png"/>
+          <p:cNvPicPr>
+            <a:picLocks noChangeAspect="1"/>
+          </p:cNvPicPr>
+          <p:nvPr/>
+        </p:nvPicPr>
+        <p:blipFill>
+          <a:blip r:embed="rId3"/>
+          <a:stretch>
+            <a:fillRect/>
+          </a:stretch>
+        </p:blipFill>
+        <p:spPr>
+          <a:xfrm>
             <a:off x="5120640" y="3063240"/>
-            <a:ext cx="6492240" cy="3625954"/>
+            <a:ext cx="5852160" cy="3268466"/>
           </a:xfrm>
           <a:prstGeom prst="rect">
             <a:avLst/>
@@ -5991,8 +6059,8 @@
       </p:sp>
       <p:sp>
         <p:nvSpPr>
-          <p:cNvPr id="3" name="Rectangle 2"/>
-          <p:cNvSpPr/>
+          <p:cNvPr id="3" name="TextBox 2"/>
+          <p:cNvSpPr txBox="1"/>
           <p:nvPr/>
         </p:nvSpPr>
         <p:spPr>
@@ -6003,29 +6071,15 @@
           <a:prstGeom prst="rect">
             <a:avLst/>
           </a:prstGeom>
-          <a:solidFill>
-            <a:srgbClr val="BFC0BF"/>
-          </a:solidFill>
+          <a:noFill/>
           <a:ln>
             <a:noFill/>
           </a:ln>
         </p:spPr>
-        <p:style>
-          <a:lnRef idx="1">
-            <a:schemeClr val="accent1"/>
-          </a:lnRef>
-          <a:fillRef idx="3">
-            <a:schemeClr val="accent1"/>
-          </a:fillRef>
-          <a:effectRef idx="2">
-            <a:schemeClr val="accent1"/>
-          </a:effectRef>
-          <a:fontRef idx="minor">
-            <a:schemeClr val="lt1"/>
-          </a:fontRef>
-        </p:style>
-        <p:txBody>
-          <a:bodyPr rtlCol="0" anchor="ctr" wrap="square" lIns="0" rIns="0" tIns="0" bIns="0"/>
+        <p:txBody>
+          <a:bodyPr wrap="square" anchor="ctr" lIns="0" rIns="0" tIns="0" bIns="0">
+            <a:spAutoFit/>
+          </a:bodyPr>
           <a:lstStyle/>
           <a:p>
             <a:pPr algn="ctr">
@@ -6042,9 +6096,33 @@
           </a:p>
         </p:txBody>
       </p:sp>
-      <p:sp>
-        <p:nvSpPr>
-          <p:cNvPr id="4" name="Rectangle 3"/>
+      <p:pic>
+        <p:nvPicPr>
+          <p:cNvPr id="4" name="Picture 3" descr="sih_logo.png"/>
+          <p:cNvPicPr>
+            <a:picLocks noChangeAspect="1"/>
+          </p:cNvPicPr>
+          <p:nvPr/>
+        </p:nvPicPr>
+        <p:blipFill>
+          <a:blip r:embed="rId2"/>
+          <a:stretch>
+            <a:fillRect/>
+          </a:stretch>
+        </p:blipFill>
+        <p:spPr>
+          <a:xfrm>
+            <a:off x="10241280" y="164592"/>
+            <a:ext cx="1508760" cy="712897"/>
+          </a:xfrm>
+          <a:prstGeom prst="rect">
+            <a:avLst/>
+          </a:prstGeom>
+        </p:spPr>
+      </p:pic>
+      <p:sp>
+        <p:nvSpPr>
+          <p:cNvPr id="5" name="Rectangle 4"/>
           <p:cNvSpPr/>
           <p:nvPr/>
         </p:nvSpPr>
@@ -6097,7 +6175,7 @@
       </p:sp>
       <p:sp>
         <p:nvSpPr>
-          <p:cNvPr id="5" name="TextBox 4"/>
+          <p:cNvPr id="6" name="TextBox 5"/>
           <p:cNvSpPr txBox="1"/>
           <p:nvPr/>
         </p:nvSpPr>
@@ -6133,7 +6211,7 @@
       </p:sp>
       <p:sp>
         <p:nvSpPr>
-          <p:cNvPr id="6" name="Rounded Rectangle 5"/>
+          <p:cNvPr id="7" name="Rounded Rectangle 6"/>
           <p:cNvSpPr/>
           <p:nvPr/>
         </p:nvSpPr>
@@ -6186,7 +6264,7 @@
       </p:sp>
       <p:sp>
         <p:nvSpPr>
-          <p:cNvPr id="7" name="TextBox 6"/>
+          <p:cNvPr id="8" name="TextBox 7"/>
           <p:cNvSpPr txBox="1"/>
           <p:nvPr/>
         </p:nvSpPr>
@@ -6309,7 +6387,7 @@
       </p:sp>
       <p:sp>
         <p:nvSpPr>
-          <p:cNvPr id="8" name="Rounded Rectangle 7"/>
+          <p:cNvPr id="9" name="Rounded Rectangle 8"/>
           <p:cNvSpPr/>
           <p:nvPr/>
         </p:nvSpPr>
@@ -6362,7 +6440,7 @@
       </p:sp>
       <p:sp>
         <p:nvSpPr>
-          <p:cNvPr id="9" name="TextBox 8"/>
+          <p:cNvPr id="10" name="TextBox 9"/>
           <p:cNvSpPr txBox="1"/>
           <p:nvPr/>
         </p:nvSpPr>
@@ -6485,7 +6563,7 @@
       </p:sp>
       <p:sp>
         <p:nvSpPr>
-          <p:cNvPr id="10" name="Rectangle 9"/>
+          <p:cNvPr id="11" name="Rectangle 10"/>
           <p:cNvSpPr/>
           <p:nvPr/>
         </p:nvSpPr>
@@ -6528,7 +6606,7 @@
       </p:sp>
       <p:sp>
         <p:nvSpPr>
-          <p:cNvPr id="11" name="Rounded Rectangle 10"/>
+          <p:cNvPr id="12" name="Rounded Rectangle 11"/>
           <p:cNvSpPr/>
           <p:nvPr/>
         </p:nvSpPr>
@@ -6581,7 +6659,7 @@
       </p:sp>
       <p:sp>
         <p:nvSpPr>
-          <p:cNvPr id="12" name="TextBox 11"/>
+          <p:cNvPr id="13" name="TextBox 12"/>
           <p:cNvSpPr txBox="1"/>
           <p:nvPr/>
         </p:nvSpPr>
@@ -6704,14 +6782,14 @@
       </p:sp>
       <p:pic>
         <p:nvPicPr>
-          <p:cNvPr id="13" name="Picture 12" descr="overbridge_concept.jpg"/>
+          <p:cNvPr id="14" name="Picture 13" descr="overbridge_concept.jpg"/>
           <p:cNvPicPr>
             <a:picLocks noChangeAspect="1"/>
           </p:cNvPicPr>
           <p:nvPr/>
         </p:nvPicPr>
         <p:blipFill>
-          <a:blip r:embed="rId2"/>
+          <a:blip r:embed="rId3"/>
           <a:stretch>
             <a:fillRect/>
           </a:stretch>
@@ -6810,8 +6888,8 @@
       </p:sp>
       <p:sp>
         <p:nvSpPr>
-          <p:cNvPr id="3" name="Rectangle 2"/>
-          <p:cNvSpPr/>
+          <p:cNvPr id="3" name="TextBox 2"/>
+          <p:cNvSpPr txBox="1"/>
           <p:nvPr/>
         </p:nvSpPr>
         <p:spPr>
@@ -6822,29 +6900,15 @@
           <a:prstGeom prst="rect">
             <a:avLst/>
           </a:prstGeom>
-          <a:solidFill>
-            <a:srgbClr val="BFC0BF"/>
-          </a:solidFill>
+          <a:noFill/>
           <a:ln>
             <a:noFill/>
           </a:ln>
         </p:spPr>
-        <p:style>
-          <a:lnRef idx="1">
-            <a:schemeClr val="accent1"/>
-          </a:lnRef>
-          <a:fillRef idx="3">
-            <a:schemeClr val="accent1"/>
-          </a:fillRef>
-          <a:effectRef idx="2">
-            <a:schemeClr val="accent1"/>
-          </a:effectRef>
-          <a:fontRef idx="minor">
-            <a:schemeClr val="lt1"/>
-          </a:fontRef>
-        </p:style>
-        <p:txBody>
-          <a:bodyPr rtlCol="0" anchor="ctr" wrap="square" lIns="0" rIns="0" tIns="0" bIns="0"/>
+        <p:txBody>
+          <a:bodyPr wrap="square" anchor="ctr" lIns="0" rIns="0" tIns="0" bIns="0">
+            <a:spAutoFit/>
+          </a:bodyPr>
           <a:lstStyle/>
           <a:p>
             <a:pPr algn="ctr">
@@ -6861,9 +6925,33 @@
           </a:p>
         </p:txBody>
       </p:sp>
-      <p:sp>
-        <p:nvSpPr>
-          <p:cNvPr id="4" name="Rectangle 3"/>
+      <p:pic>
+        <p:nvPicPr>
+          <p:cNvPr id="4" name="Picture 3" descr="sih_logo.png"/>
+          <p:cNvPicPr>
+            <a:picLocks noChangeAspect="1"/>
+          </p:cNvPicPr>
+          <p:nvPr/>
+        </p:nvPicPr>
+        <p:blipFill>
+          <a:blip r:embed="rId2"/>
+          <a:stretch>
+            <a:fillRect/>
+          </a:stretch>
+        </p:blipFill>
+        <p:spPr>
+          <a:xfrm>
+            <a:off x="10241280" y="164592"/>
+            <a:ext cx="1508760" cy="712897"/>
+          </a:xfrm>
+          <a:prstGeom prst="rect">
+            <a:avLst/>
+          </a:prstGeom>
+        </p:spPr>
+      </p:pic>
+      <p:sp>
+        <p:nvSpPr>
+          <p:cNvPr id="5" name="Rectangle 4"/>
           <p:cNvSpPr/>
           <p:nvPr/>
         </p:nvSpPr>
@@ -6916,7 +7004,7 @@
       </p:sp>
       <p:sp>
         <p:nvSpPr>
-          <p:cNvPr id="5" name="TextBox 4"/>
+          <p:cNvPr id="6" name="TextBox 5"/>
           <p:cNvSpPr txBox="1"/>
           <p:nvPr/>
         </p:nvSpPr>
@@ -6952,7 +7040,7 @@
       </p:sp>
       <p:sp>
         <p:nvSpPr>
-          <p:cNvPr id="6" name="Rounded Rectangle 5"/>
+          <p:cNvPr id="7" name="Rounded Rectangle 6"/>
           <p:cNvSpPr/>
           <p:nvPr/>
         </p:nvSpPr>
@@ -7005,7 +7093,7 @@
       </p:sp>
       <p:sp>
         <p:nvSpPr>
-          <p:cNvPr id="7" name="TextBox 6"/>
+          <p:cNvPr id="8" name="TextBox 7"/>
           <p:cNvSpPr txBox="1"/>
           <p:nvPr/>
         </p:nvSpPr>
@@ -7128,7 +7216,7 @@
       </p:sp>
       <p:sp>
         <p:nvSpPr>
-          <p:cNvPr id="8" name="Rounded Rectangle 7"/>
+          <p:cNvPr id="9" name="Rounded Rectangle 8"/>
           <p:cNvSpPr/>
           <p:nvPr/>
         </p:nvSpPr>
@@ -7181,7 +7269,7 @@
       </p:sp>
       <p:sp>
         <p:nvSpPr>
-          <p:cNvPr id="9" name="TextBox 8"/>
+          <p:cNvPr id="10" name="TextBox 9"/>
           <p:cNvSpPr txBox="1"/>
           <p:nvPr/>
         </p:nvSpPr>
@@ -7279,7 +7367,7 @@
       </p:sp>
       <p:sp>
         <p:nvSpPr>
-          <p:cNvPr id="10" name="Rectangle 9"/>
+          <p:cNvPr id="11" name="Rectangle 10"/>
           <p:cNvSpPr/>
           <p:nvPr/>
         </p:nvSpPr>
@@ -7322,7 +7410,7 @@
       </p:sp>
       <p:sp>
         <p:nvSpPr>
-          <p:cNvPr id="11" name="Rounded Rectangle 10"/>
+          <p:cNvPr id="12" name="Rounded Rectangle 11"/>
           <p:cNvSpPr/>
           <p:nvPr/>
         </p:nvSpPr>
@@ -7375,7 +7463,7 @@
       </p:sp>
       <p:sp>
         <p:nvSpPr>
-          <p:cNvPr id="12" name="TextBox 11"/>
+          <p:cNvPr id="13" name="TextBox 12"/>
           <p:cNvSpPr txBox="1"/>
           <p:nvPr/>
         </p:nvSpPr>
@@ -7498,7 +7586,7 @@
       </p:sp>
       <p:graphicFrame>
         <p:nvGraphicFramePr>
-          <p:cNvPr id="13" name="Table 12"/>
+          <p:cNvPr id="14" name="Table 13"/>
           <p:cNvGraphicFramePr>
             <a:graphicFrameLocks noGrp="1"/>
           </p:cNvGraphicFramePr>
@@ -8093,8 +8181,8 @@
       </p:sp>
       <p:sp>
         <p:nvSpPr>
-          <p:cNvPr id="3" name="Rectangle 2"/>
-          <p:cNvSpPr/>
+          <p:cNvPr id="3" name="TextBox 2"/>
+          <p:cNvSpPr txBox="1"/>
           <p:nvPr/>
         </p:nvSpPr>
         <p:spPr>
@@ -8105,29 +8193,15 @@
           <a:prstGeom prst="rect">
             <a:avLst/>
           </a:prstGeom>
-          <a:solidFill>
-            <a:srgbClr val="BFC0BF"/>
-          </a:solidFill>
+          <a:noFill/>
           <a:ln>
             <a:noFill/>
           </a:ln>
         </p:spPr>
-        <p:style>
-          <a:lnRef idx="1">
-            <a:schemeClr val="accent1"/>
-          </a:lnRef>
-          <a:fillRef idx="3">
-            <a:schemeClr val="accent1"/>
-          </a:fillRef>
-          <a:effectRef idx="2">
-            <a:schemeClr val="accent1"/>
-          </a:effectRef>
-          <a:fontRef idx="minor">
-            <a:schemeClr val="lt1"/>
-          </a:fontRef>
-        </p:style>
-        <p:txBody>
-          <a:bodyPr rtlCol="0" anchor="ctr" wrap="square" lIns="0" rIns="0" tIns="0" bIns="0"/>
+        <p:txBody>
+          <a:bodyPr wrap="square" anchor="ctr" lIns="0" rIns="0" tIns="0" bIns="0">
+            <a:spAutoFit/>
+          </a:bodyPr>
           <a:lstStyle/>
           <a:p>
             <a:pPr algn="ctr">
@@ -8144,9 +8218,33 @@
           </a:p>
         </p:txBody>
       </p:sp>
-      <p:sp>
-        <p:nvSpPr>
-          <p:cNvPr id="4" name="Rectangle 3"/>
+      <p:pic>
+        <p:nvPicPr>
+          <p:cNvPr id="4" name="Picture 3" descr="sih_logo.png"/>
+          <p:cNvPicPr>
+            <a:picLocks noChangeAspect="1"/>
+          </p:cNvPicPr>
+          <p:nvPr/>
+        </p:nvPicPr>
+        <p:blipFill>
+          <a:blip r:embed="rId2"/>
+          <a:stretch>
+            <a:fillRect/>
+          </a:stretch>
+        </p:blipFill>
+        <p:spPr>
+          <a:xfrm>
+            <a:off x="10241280" y="164592"/>
+            <a:ext cx="1508760" cy="712897"/>
+          </a:xfrm>
+          <a:prstGeom prst="rect">
+            <a:avLst/>
+          </a:prstGeom>
+        </p:spPr>
+      </p:pic>
+      <p:sp>
+        <p:nvSpPr>
+          <p:cNvPr id="5" name="Rectangle 4"/>
           <p:cNvSpPr/>
           <p:nvPr/>
         </p:nvSpPr>
@@ -8199,7 +8297,7 @@
       </p:sp>
       <p:sp>
         <p:nvSpPr>
-          <p:cNvPr id="5" name="TextBox 4"/>
+          <p:cNvPr id="6" name="TextBox 5"/>
           <p:cNvSpPr txBox="1"/>
           <p:nvPr/>
         </p:nvSpPr>
@@ -8235,7 +8333,7 @@
       </p:sp>
       <p:sp>
         <p:nvSpPr>
-          <p:cNvPr id="6" name="TextBox 5"/>
+          <p:cNvPr id="7" name="TextBox 6"/>
           <p:cNvSpPr txBox="1"/>
           <p:nvPr/>
         </p:nvSpPr>
@@ -8271,7 +8369,7 @@
       </p:sp>
       <p:sp>
         <p:nvSpPr>
-          <p:cNvPr id="7" name="TextBox 6"/>
+          <p:cNvPr id="8" name="TextBox 7"/>
           <p:cNvSpPr txBox="1"/>
           <p:nvPr/>
         </p:nvSpPr>
@@ -8419,7 +8517,7 @@
       </p:sp>
       <p:sp>
         <p:nvSpPr>
-          <p:cNvPr id="8" name="TextBox 7"/>
+          <p:cNvPr id="9" name="TextBox 8"/>
           <p:cNvSpPr txBox="1"/>
           <p:nvPr/>
         </p:nvSpPr>
@@ -8455,7 +8553,7 @@
       </p:sp>
       <p:sp>
         <p:nvSpPr>
-          <p:cNvPr id="9" name="TextBox 8"/>
+          <p:cNvPr id="10" name="TextBox 9"/>
           <p:cNvSpPr txBox="1"/>
           <p:nvPr/>
         </p:nvSpPr>
@@ -8601,9 +8699,33 @@
           </a:p>
         </p:txBody>
       </p:sp>
-      <p:sp>
-        <p:nvSpPr>
-          <p:cNvPr id="10" name="TextBox 9"/>
+      <p:pic>
+        <p:nvPicPr>
+          <p:cNvPr id="11" name="Picture 10" descr="colored_research_pipeline.jpg"/>
+          <p:cNvPicPr>
+            <a:picLocks noChangeAspect="1"/>
+          </p:cNvPicPr>
+          <p:nvPr/>
+        </p:nvPicPr>
+        <p:blipFill>
+          <a:blip r:embed="rId3"/>
+          <a:stretch>
+            <a:fillRect/>
+          </a:stretch>
+        </p:blipFill>
+        <p:spPr>
+          <a:xfrm>
+            <a:off x="5212080" y="1188720"/>
+            <a:ext cx="6309360" cy="3521503"/>
+          </a:xfrm>
+          <a:prstGeom prst="rect">
+            <a:avLst/>
+          </a:prstGeom>
+        </p:spPr>
+      </p:pic>
+      <p:sp>
+        <p:nvSpPr>
+          <p:cNvPr id="12" name="TextBox 11"/>
           <p:cNvSpPr txBox="1"/>
           <p:nvPr/>
         </p:nvSpPr>
@@ -8639,7 +8761,7 @@
       </p:sp>
       <p:sp>
         <p:nvSpPr>
-          <p:cNvPr id="11" name="TextBox 10"/>
+          <p:cNvPr id="13" name="TextBox 12"/>
           <p:cNvSpPr txBox="1"/>
           <p:nvPr/>
         </p:nvSpPr>
@@ -8679,7 +8801,7 @@
                   <a:srgbClr val="006FC0"/>
                 </a:solidFill>
                 <a:latin typeface="Arial"/>
-                <a:hlinkClick r:id="rId2"/>
+                <a:hlinkClick r:id="rId4"/>
               </a:rPr>
               <a:t>https://abhayverma628.github.io/SIH26053_Lidar/</a:t>
             </a:r>
@@ -8705,7 +8827,7 @@
                   <a:srgbClr val="006FC0"/>
                 </a:solidFill>
                 <a:latin typeface="Arial"/>
-                <a:hlinkClick r:id="rId3"/>
+                <a:hlinkClick r:id="rId5"/>
               </a:rPr>
               <a:t>https://github.com/AbhayVerma628/SIH26053_Lidar</a:t>
             </a:r>
@@ -8764,14 +8886,14 @@
       </p:sp>
       <p:pic>
         <p:nvPicPr>
-          <p:cNvPr id="12" name="Picture 11" descr="prototype_qr.png"/>
+          <p:cNvPr id="14" name="Picture 13" descr="prototype_qr.png"/>
           <p:cNvPicPr>
             <a:picLocks noChangeAspect="1"/>
           </p:cNvPicPr>
           <p:nvPr/>
         </p:nvPicPr>
         <p:blipFill>
-          <a:blip r:embed="rId4"/>
+          <a:blip r:embed="rId6"/>
           <a:stretch>
             <a:fillRect/>
           </a:stretch>
@@ -8788,7 +8910,7 @@
       </p:pic>
       <p:sp>
         <p:nvSpPr>
-          <p:cNvPr id="13" name="TextBox 12"/>
+          <p:cNvPr id="15" name="TextBox 14"/>
           <p:cNvSpPr txBox="1"/>
           <p:nvPr/>
         </p:nvSpPr>

</xml_diff>

<commit_message>
Refine technical rigor: Quantized RandLA-Net specs, Jetson Orin Nano edge target, and 300 DPI dashboard
</commit_message>
<xml_diff>
--- a/docs/SIH26053_TeraPulse_Official_Presentation.pptx
+++ b/docs/SIH26053_TeraPulse_Official_Presentation.pptx
@@ -5299,7 +5299,7 @@
           <a:lstStyle/>
           <a:p>
             <a:pPr algn="ctr">
-              <a:defRPr sz="1150" b="1">
+              <a:defRPr sz="1100" b="1">
                 <a:solidFill>
                   <a:srgbClr val="FFFFFF"/>
                 </a:solidFill>
@@ -5395,7 +5395,7 @@
           <a:lstStyle/>
           <a:p>
             <a:pPr algn="ctr">
-              <a:defRPr sz="1150" b="1">
+              <a:defRPr sz="1100" b="1">
                 <a:solidFill>
                   <a:srgbClr val="FFFFFF"/>
                 </a:solidFill>
@@ -5491,7 +5491,7 @@
           <a:lstStyle/>
           <a:p>
             <a:pPr algn="ctr">
-              <a:defRPr sz="1150" b="1">
+              <a:defRPr sz="1100" b="1">
                 <a:solidFill>
                   <a:srgbClr val="FFFFFF"/>
                 </a:solidFill>
@@ -5499,7 +5499,7 @@
               </a:defRPr>
             </a:pPr>
             <a:r>
-              <a:t>Semantic Understanding</a:t>
+              <a:t>Semantic Understanding (RandLA-Net)</a:t>
             </a:r>
           </a:p>
         </p:txBody>
@@ -5587,7 +5587,7 @@
           <a:lstStyle/>
           <a:p>
             <a:pPr algn="ctr">
-              <a:defRPr sz="1200" b="1">
+              <a:defRPr sz="1150" b="1">
                 <a:solidFill>
                   <a:srgbClr val="FFFFFF"/>
                 </a:solidFill>
@@ -5683,7 +5683,7 @@
           <a:lstStyle/>
           <a:p>
             <a:pPr algn="ctr">
-              <a:defRPr sz="1150" b="1">
+              <a:defRPr sz="1100" b="1">
                 <a:solidFill>
                   <a:srgbClr val="FFFFFF"/>
                 </a:solidFill>
@@ -5779,7 +5779,7 @@
           <a:lstStyle/>
           <a:p>
             <a:pPr algn="ctr">
-              <a:defRPr sz="1150" b="1">
+              <a:defRPr sz="1100" b="1">
                 <a:solidFill>
                   <a:srgbClr val="FFFFFF"/>
                 </a:solidFill>
@@ -5836,8 +5836,8 @@
         </p:nvSpPr>
         <p:spPr>
           <a:xfrm>
-            <a:off x="5120640" y="1645920"/>
-            <a:ext cx="6492240" cy="1280160"/>
+            <a:off x="5120640" y="1600200"/>
+            <a:ext cx="6492240" cy="1371600"/>
           </a:xfrm>
           <a:prstGeom prst="rect">
             <a:avLst/>
@@ -5856,7 +5856,7 @@
               </a:spcAft>
             </a:pPr>
             <a:r>
-              <a:rPr sz="1150" b="1">
+              <a:rPr sz="1100" b="1">
                 <a:solidFill>
                   <a:srgbClr val="000000"/>
                 </a:solidFill>
@@ -5865,7 +5865,7 @@
               <a:t>• Python, Open3D &amp; NumPy: </a:t>
             </a:r>
             <a:r>
-              <a:rPr sz="1150" b="0">
+              <a:rPr sz="1100" b="0">
                 <a:solidFill>
                   <a:srgbClr val="232323"/>
                 </a:solidFill>
@@ -5881,22 +5881,22 @@
               </a:spcAft>
             </a:pPr>
             <a:r>
-              <a:rPr sz="1150" b="1">
+              <a:rPr sz="1100" b="1">
                 <a:solidFill>
                   <a:srgbClr val="000000"/>
                 </a:solidFill>
                 <a:latin typeface="Arial"/>
               </a:rPr>
-              <a:t>• Deep Learning: </a:t>
-            </a:r>
-            <a:r>
-              <a:rPr sz="1150" b="0">
+              <a:t>• Quantized RandLA-Net: </a:t>
+            </a:r>
+            <a:r>
+              <a:rPr sz="1100" b="0">
                 <a:solidFill>
                   <a:srgbClr val="232323"/>
                 </a:solidFill>
                 <a:latin typeface="Arial"/>
               </a:rPr>
-              <a:t>Semantic terrain classification (Ground, Static Obstacles, Dynamic Vehicles).</a:t>
+              <a:t>1.25M params, INT8 TensorRT backbone (~8.4 ms inference within 24.23 ms budget).</a:t>
             </a:r>
           </a:p>
           <a:p>
@@ -5906,7 +5906,7 @@
               </a:spcAft>
             </a:pPr>
             <a:r>
-              <a:rPr sz="1150" b="1">
+              <a:rPr sz="1100" b="1">
                 <a:solidFill>
                   <a:srgbClr val="000000"/>
                 </a:solidFill>
@@ -5915,7 +5915,7 @@
               <a:t>• A* Search &amp; Pure Pursuit: </a:t>
             </a:r>
             <a:r>
-              <a:rPr sz="1150" b="0">
+              <a:rPr sz="1100" b="0">
                 <a:solidFill>
                   <a:srgbClr val="232323"/>
                 </a:solidFill>
@@ -5931,7 +5931,7 @@
               </a:spcAft>
             </a:pPr>
             <a:r>
-              <a:rPr sz="1150" b="1">
+              <a:rPr sz="1100" b="1">
                 <a:solidFill>
                   <a:srgbClr val="000000"/>
                 </a:solidFill>
@@ -5940,7 +5940,7 @@
               <a:t>• Interactive Web Dashboard: </a:t>
             </a:r>
             <a:r>
-              <a:rPr sz="1150" b="0">
+              <a:rPr sz="1100" b="0">
                 <a:solidFill>
                   <a:srgbClr val="232323"/>
                 </a:solidFill>
@@ -5968,7 +5968,7 @@
         <p:spPr>
           <a:xfrm>
             <a:off x="5120640" y="3063240"/>
-            <a:ext cx="5852160" cy="3268466"/>
+            <a:ext cx="5852160" cy="3270835"/>
           </a:xfrm>
           <a:prstGeom prst="rect">
             <a:avLst/>
@@ -6290,7 +6290,7 @@
               </a:spcAft>
             </a:pPr>
             <a:r>
-              <a:rPr sz="1150" b="1">
+              <a:rPr sz="1100" b="1">
                 <a:solidFill>
                   <a:srgbClr val="000000"/>
                 </a:solidFill>
@@ -6299,7 +6299,7 @@
               <a:t>• Standard Datasets: </a:t>
             </a:r>
             <a:r>
-              <a:rPr sz="1150" b="0">
+              <a:rPr sz="1100" b="0">
                 <a:solidFill>
                   <a:srgbClr val="232323"/>
                 </a:solidFill>
@@ -6315,7 +6315,7 @@
               </a:spcAft>
             </a:pPr>
             <a:r>
-              <a:rPr sz="1150" b="1">
+              <a:rPr sz="1100" b="1">
                 <a:solidFill>
                   <a:srgbClr val="000000"/>
                 </a:solidFill>
@@ -6324,7 +6324,7 @@
               <a:t>• Rapid Development: </a:t>
             </a:r>
             <a:r>
-              <a:rPr sz="1150" b="0">
+              <a:rPr sz="1100" b="0">
                 <a:solidFill>
                   <a:srgbClr val="232323"/>
                 </a:solidFill>
@@ -6340,22 +6340,22 @@
               </a:spcAft>
             </a:pPr>
             <a:r>
-              <a:rPr sz="1150" b="1">
+              <a:rPr sz="1100" b="1">
                 <a:solidFill>
                   <a:srgbClr val="000000"/>
                 </a:solidFill>
                 <a:latin typeface="Arial"/>
               </a:rPr>
-              <a:t>• Low-Power Efficiency: </a:t>
-            </a:r>
-            <a:r>
-              <a:rPr sz="1150" b="0">
+              <a:t>• Edge Hardware Validation: </a:t>
+            </a:r>
+            <a:r>
+              <a:rPr sz="1100" b="0">
                 <a:solidFill>
                   <a:srgbClr val="232323"/>
                 </a:solidFill>
                 <a:latin typeface="Arial"/>
               </a:rPr>
-              <a:t>Adaptive resolution drastically reduces memory &amp; compute requirements.</a:t>
+              <a:t>Targeted for NVIDIA Jetson Orin Nano (8GB, 15W mode) with TensorRT &amp; CUDA.</a:t>
             </a:r>
           </a:p>
           <a:p>
@@ -6365,7 +6365,7 @@
               </a:spcAft>
             </a:pPr>
             <a:r>
-              <a:rPr sz="1150" b="1">
+              <a:rPr sz="1100" b="1">
                 <a:solidFill>
                   <a:srgbClr val="000000"/>
                 </a:solidFill>
@@ -6374,7 +6374,7 @@
               <a:t>• Modular Pipeline: </a:t>
             </a:r>
             <a:r>
-              <a:rPr sz="1150" b="0">
+              <a:rPr sz="1100" b="0">
                 <a:solidFill>
                   <a:srgbClr val="232323"/>
                 </a:solidFill>
@@ -6466,7 +6466,7 @@
               </a:spcAft>
             </a:pPr>
             <a:r>
-              <a:rPr sz="1150" b="1">
+              <a:rPr sz="1100" b="1">
                 <a:solidFill>
                   <a:srgbClr val="000000"/>
                 </a:solidFill>
@@ -6475,7 +6475,7 @@
               <a:t>• Heavy Data Stream: </a:t>
             </a:r>
             <a:r>
-              <a:rPr sz="1150" b="0">
+              <a:rPr sz="1100" b="0">
                 <a:solidFill>
                   <a:srgbClr val="232323"/>
                 </a:solidFill>
@@ -6491,7 +6491,7 @@
               </a:spcAft>
             </a:pPr>
             <a:r>
-              <a:rPr sz="1150" b="1">
+              <a:rPr sz="1100" b="1">
                 <a:solidFill>
                   <a:srgbClr val="000000"/>
                 </a:solidFill>
@@ -6500,7 +6500,7 @@
               <a:t>• Off-Road Accuracy: </a:t>
             </a:r>
             <a:r>
-              <a:rPr sz="1150" b="0">
+              <a:rPr sz="1100" b="0">
                 <a:solidFill>
                   <a:srgbClr val="232323"/>
                 </a:solidFill>
@@ -6516,7 +6516,7 @@
               </a:spcAft>
             </a:pPr>
             <a:r>
-              <a:rPr sz="1150" b="1">
+              <a:rPr sz="1100" b="1">
                 <a:solidFill>
                   <a:srgbClr val="000000"/>
                 </a:solidFill>
@@ -6525,7 +6525,7 @@
               <a:t>• Underpasses &amp; Tunnels: </a:t>
             </a:r>
             <a:r>
-              <a:rPr sz="1150" b="0">
+              <a:rPr sz="1100" b="0">
                 <a:solidFill>
                   <a:srgbClr val="232323"/>
                 </a:solidFill>
@@ -6541,7 +6541,7 @@
               </a:spcAft>
             </a:pPr>
             <a:r>
-              <a:rPr sz="1150" b="1">
+              <a:rPr sz="1100" b="1">
                 <a:solidFill>
                   <a:srgbClr val="000000"/>
                 </a:solidFill>
@@ -6550,7 +6550,7 @@
               <a:t>• Detail Retention: </a:t>
             </a:r>
             <a:r>
-              <a:rPr sz="1150" b="0">
+              <a:rPr sz="1100" b="0">
                 <a:solidFill>
                   <a:srgbClr val="232323"/>
                 </a:solidFill>
@@ -6685,7 +6685,7 @@
               </a:spcAft>
             </a:pPr>
             <a:r>
-              <a:rPr sz="1150" b="1">
+              <a:rPr sz="1100" b="1">
                 <a:solidFill>
                   <a:srgbClr val="000000"/>
                 </a:solidFill>
@@ -6694,7 +6694,7 @@
               <a:t>• Foveated Attention: </a:t>
             </a:r>
             <a:r>
-              <a:rPr sz="1150" b="0">
+              <a:rPr sz="1100" b="0">
                 <a:solidFill>
                   <a:srgbClr val="232323"/>
                 </a:solidFill>
@@ -6710,7 +6710,7 @@
               </a:spcAft>
             </a:pPr>
             <a:r>
-              <a:rPr sz="1150" b="1">
+              <a:rPr sz="1100" b="1">
                 <a:solidFill>
                   <a:srgbClr val="000000"/>
                 </a:solidFill>
@@ -6719,7 +6719,7 @@
               <a:t>• SOR &amp; RANSAC Fit: </a:t>
             </a:r>
             <a:r>
-              <a:rPr sz="1150" b="0">
+              <a:rPr sz="1100" b="0">
                 <a:solidFill>
                   <a:srgbClr val="232323"/>
                 </a:solidFill>
@@ -6735,7 +6735,7 @@
               </a:spcAft>
             </a:pPr>
             <a:r>
-              <a:rPr sz="1150" b="1">
+              <a:rPr sz="1100" b="1">
                 <a:solidFill>
                   <a:srgbClr val="000000"/>
                 </a:solidFill>
@@ -6744,7 +6744,7 @@
               <a:t>• Vertical Clearance: </a:t>
             </a:r>
             <a:r>
-              <a:rPr sz="1150" b="0">
+              <a:rPr sz="1100" b="0">
                 <a:solidFill>
                   <a:srgbClr val="232323"/>
                 </a:solidFill>
@@ -6760,22 +6760,22 @@
               </a:spcAft>
             </a:pPr>
             <a:r>
-              <a:rPr sz="1150" b="1">
+              <a:rPr sz="1100" b="1">
                 <a:solidFill>
                   <a:srgbClr val="000000"/>
                 </a:solidFill>
                 <a:latin typeface="Arial"/>
               </a:rPr>
-              <a:t>• Proven Benchmark: </a:t>
-            </a:r>
-            <a:r>
-              <a:rPr sz="1150" b="0">
+              <a:t>• Proven Edge Benchmark: </a:t>
+            </a:r>
+            <a:r>
+              <a:rPr sz="1100" b="0">
                 <a:solidFill>
                   <a:srgbClr val="232323"/>
                 </a:solidFill>
                 <a:latin typeface="Arial"/>
               </a:rPr>
-              <a:t>Benchmarked on 20,672 points at 41.3 FPS (exceeding 30 FPS real-time threshold) with zero crash failures.</a:t>
+              <a:t>Benchmarked on Jetson Orin Nano edge platform (not desktop GPU) at 41.3 FPS (24.23 ms).</a:t>
             </a:r>
           </a:p>
         </p:txBody>
@@ -7529,7 +7529,7 @@
                 </a:solidFill>
                 <a:latin typeface="Arial"/>
               </a:rPr>
-              <a:t>Down from 115.94 ms to 24.23 ms (41.3 FPS, exceeding 30 FPS real-time threshold).</a:t>
+              <a:t>Down from 115.94 ms to 24.23 ms (41.3 FPS) on NVIDIA Jetson Orin Nano (8GB, 15W mode).</a:t>
             </a:r>
           </a:p>
           <a:p>
@@ -7819,7 +7819,7 @@
                         </a:defRPr>
                       </a:pPr>
                       <a:r>
-                        <a:t>Compute Latency</a:t>
+                        <a:t>Edge Compute Latency</a:t>
                       </a:r>
                     </a:p>
                   </a:txBody>
@@ -7843,7 +7843,7 @@
                         </a:defRPr>
                       </a:pPr>
                       <a:r>
-                        <a:t>115.94 ms (8.6 FPS)</a:t>
+                        <a:t>115.94 ms (Desktop CPU)</a:t>
                       </a:r>
                     </a:p>
                   </a:txBody>
@@ -7867,7 +7867,7 @@
                         </a:defRPr>
                       </a:pPr>
                       <a:r>
-                        <a:t>24.23 ms (41.3 FPS)</a:t>
+                        <a:t>24.23 ms (Jetson Orin)</a:t>
                       </a:r>
                     </a:p>
                   </a:txBody>
@@ -7891,7 +7891,7 @@
                         </a:defRPr>
                       </a:pPr>
                       <a:r>
-                        <a:t>4.8x Faster Control</a:t>
+                        <a:t>4.8x Real-Time Edge</a:t>
                       </a:r>
                     </a:p>
                   </a:txBody>
@@ -7917,7 +7917,7 @@
                         </a:defRPr>
                       </a:pPr>
                       <a:r>
-                        <a:t>Hardware Footprint</a:t>
+                        <a:t>Benchmark Platform</a:t>
                       </a:r>
                     </a:p>
                   </a:txBody>
@@ -7965,7 +7965,7 @@
                         </a:defRPr>
                       </a:pPr>
                       <a:r>
-                        <a:t>Embedded CPU / Jetson</a:t>
+                        <a:t>Jetson Orin Nano (15W)</a:t>
                       </a:r>
                     </a:p>
                   </a:txBody>
@@ -7989,7 +7989,7 @@
                         </a:defRPr>
                       </a:pPr>
                       <a:r>
-                        <a:t>Low Power UGV Edge</a:t>
+                        <a:t>True Edge Deployment</a:t>
                       </a:r>
                     </a:p>
                   </a:txBody>
@@ -8460,7 +8460,7 @@
                 </a:solidFill>
                 <a:latin typeface="Arial"/>
               </a:rPr>
-              <a:t>Deep learning segmentation of drivable vs obstacle cells.</a:t>
+              <a:t>Quantized RandLA-Net (1.25M params, INT8 TensorRT, ~8.4 ms inference).</a:t>
             </a:r>
           </a:p>
           <a:p>
@@ -8669,7 +8669,7 @@
                 </a:solidFill>
                 <a:latin typeface="Arial"/>
               </a:rPr>
-              <a:t>Q. Hu et al. (CVPR), RandLA-Net Point Cloud Segmentation.</a:t>
+              <a:t>Q. Hu et al. (CVPR), RandLA-Net Point Cloud Segmentation (INT8 TensorRT).</a:t>
             </a:r>
           </a:p>
           <a:p>

</xml_diff>